<commit_message>
P0 polish: design-system 2.0 + WPS master theme + 11pt floor + embedded vector icons
- Design system 2.0 tokens (8pt grid, type scale, spacing) shared by both engines; docs in references/design-system.md
- python-pptx engine: brand colors + Microsoft YaHei written into slide-master theme1.xml (editable via PPT/WPS Colors/Fonts panels, WPS-compatible)
- Readability floor 11pt + line-length truncation (ellipsis) replaces tiny-shrink; footer stays 9pt
- Embedded offline linear icon set (scripts/icons.py, ~50 icons) auto-mapped per slide type; hifi embeds SVG path, python-pptx uses native OOXML custGeom (no bitmap renderer, WPS-safe)
- Validated: 12 slides, 0 empty, 0 placeholders, 0 out-of-bounds, 12 transitions, vector icons present, body >=11pt
</commit_message>
<xml_diff>
--- a/output/deck.pptx
+++ b/output/deck.pptx
@@ -3227,13 +3227,176 @@
       <p:grpSpPr/>
       <p:sp>
         <p:nvSpPr>
-          <p:cNvPr id="2" name="TextBox 1"/>
+          <p:cNvPr id="2" name="Rectangle 1"/>
+          <p:cNvSpPr/>
+          <p:nvPr/>
+        </p:nvSpPr>
+        <p:spPr>
+          <a:xfrm>
+            <a:off x="5733288" y="1371600"/>
+            <a:ext cx="731520" cy="731520"/>
+          </a:xfrm>
+          <a:noFill/>
+          <a:ln w="19050">
+            <a:solidFill>
+              <a:srgbClr val="D4A060"/>
+            </a:solidFill>
+          </a:ln>
+          <a:effectLst/>
+          <a:custGeom>
+            <a:pathLst>
+              <a:path w="100000" h="100000">
+                <a:moveTo>
+                  <a:pt x="40000" y="14000"/>
+                </a:moveTo>
+                <a:lnTo>
+                  <a:pt x="60000" y="20000"/>
+                </a:lnTo>
+                <a:lnTo>
+                  <a:pt x="58000" y="54000"/>
+                </a:lnTo>
+                <a:lnTo>
+                  <a:pt x="42000" y="54000"/>
+                </a:lnTo>
+                <a:lnTo>
+                  <a:pt x="40000" y="14000"/>
+                </a:lnTo>
+                <a:close/>
+              </a:path>
+              <a:path w="100000" h="100000">
+                <a:moveTo>
+                  <a:pt x="42000" y="54000"/>
+                </a:moveTo>
+                <a:lnTo>
+                  <a:pt x="34000" y="70000"/>
+                </a:lnTo>
+                <a:lnTo>
+                  <a:pt x="44000" y="64000"/>
+                </a:lnTo>
+              </a:path>
+              <a:path w="100000" h="100000">
+                <a:moveTo>
+                  <a:pt x="58000" y="54000"/>
+                </a:moveTo>
+                <a:lnTo>
+                  <a:pt x="66000" y="70000"/>
+                </a:lnTo>
+                <a:lnTo>
+                  <a:pt x="56000" y="64000"/>
+                </a:lnTo>
+              </a:path>
+              <a:path w="100000" h="100000">
+                <a:moveTo>
+                  <a:pt x="56000" y="30000"/>
+                </a:moveTo>
+                <a:lnTo>
+                  <a:pt x="55795" y="31552"/>
+                </a:lnTo>
+                <a:lnTo>
+                  <a:pt x="55196" y="33000"/>
+                </a:lnTo>
+                <a:lnTo>
+                  <a:pt x="54242" y="34242"/>
+                </a:lnTo>
+                <a:lnTo>
+                  <a:pt x="53000" y="35196"/>
+                </a:lnTo>
+                <a:lnTo>
+                  <a:pt x="51552" y="35795"/>
+                </a:lnTo>
+                <a:lnTo>
+                  <a:pt x="50000" y="36000"/>
+                </a:lnTo>
+                <a:lnTo>
+                  <a:pt x="48447" y="35795"/>
+                </a:lnTo>
+                <a:lnTo>
+                  <a:pt x="47000" y="35196"/>
+                </a:lnTo>
+                <a:lnTo>
+                  <a:pt x="45757" y="34242"/>
+                </a:lnTo>
+                <a:lnTo>
+                  <a:pt x="44803" y="33000"/>
+                </a:lnTo>
+                <a:lnTo>
+                  <a:pt x="44204" y="31552"/>
+                </a:lnTo>
+                <a:lnTo>
+                  <a:pt x="44000" y="30000"/>
+                </a:lnTo>
+                <a:lnTo>
+                  <a:pt x="44204" y="28447"/>
+                </a:lnTo>
+                <a:lnTo>
+                  <a:pt x="44803" y="27000"/>
+                </a:lnTo>
+                <a:lnTo>
+                  <a:pt x="45757" y="25757"/>
+                </a:lnTo>
+                <a:lnTo>
+                  <a:pt x="47000" y="24803"/>
+                </a:lnTo>
+                <a:lnTo>
+                  <a:pt x="48447" y="24204"/>
+                </a:lnTo>
+                <a:lnTo>
+                  <a:pt x="50000" y="24000"/>
+                </a:lnTo>
+                <a:lnTo>
+                  <a:pt x="51552" y="24204"/>
+                </a:lnTo>
+                <a:lnTo>
+                  <a:pt x="53000" y="24803"/>
+                </a:lnTo>
+                <a:lnTo>
+                  <a:pt x="54242" y="25757"/>
+                </a:lnTo>
+                <a:lnTo>
+                  <a:pt x="55196" y="26999"/>
+                </a:lnTo>
+                <a:lnTo>
+                  <a:pt x="55795" y="28447"/>
+                </a:lnTo>
+                <a:lnTo>
+                  <a:pt x="56000" y="30000"/>
+                </a:lnTo>
+                <a:close/>
+              </a:path>
+            </a:pathLst>
+          </a:custGeom>
+        </p:spPr>
+        <p:style>
+          <a:lnRef idx="1">
+            <a:schemeClr val="accent1"/>
+          </a:lnRef>
+          <a:fillRef idx="3">
+            <a:schemeClr val="accent1"/>
+          </a:fillRef>
+          <a:effectRef idx="2">
+            <a:schemeClr val="accent1"/>
+          </a:effectRef>
+          <a:fontRef idx="minor">
+            <a:schemeClr val="lt1"/>
+          </a:fontRef>
+        </p:style>
+        <p:txBody>
+          <a:bodyPr rtlCol="0" anchor="ctr"/>
+          <a:lstStyle/>
+          <a:p>
+            <a:pPr algn="ctr"/>
+          </a:p>
+        </p:txBody>
+      </p:sp>
+      <p:sp>
+        <p:nvSpPr>
+          <p:cNvPr id="3" name="TextBox 2"/>
           <p:cNvSpPr txBox="1"/>
           <p:nvPr/>
         </p:nvSpPr>
         <p:spPr>
           <a:xfrm>
-            <a:off x="914400" y="2103120"/>
+            <a:off x="914400" y="2377440"/>
             <a:ext cx="10332720" cy="1371600"/>
           </a:xfrm>
           <a:prstGeom prst="rect">
@@ -3243,7 +3406,7 @@
         </p:spPr>
         <p:txBody>
           <a:bodyPr wrap="square" anchor="t" lIns="45720" rIns="45720">
-            <a:normAutofit/>
+            <a:spAutoFit/>
           </a:bodyPr>
           <a:lstStyle/>
           <a:p>
@@ -3262,13 +3425,13 @@
       </p:sp>
       <p:sp>
         <p:nvSpPr>
-          <p:cNvPr id="3" name="TextBox 2"/>
+          <p:cNvPr id="4" name="TextBox 3"/>
           <p:cNvSpPr txBox="1"/>
           <p:nvPr/>
         </p:nvSpPr>
         <p:spPr>
           <a:xfrm>
-            <a:off x="914400" y="3566160"/>
+            <a:off x="914400" y="3840480"/>
             <a:ext cx="10332720" cy="731520"/>
           </a:xfrm>
           <a:prstGeom prst="rect">
@@ -3278,7 +3441,7 @@
         </p:spPr>
         <p:txBody>
           <a:bodyPr wrap="square" anchor="t" lIns="45720" rIns="45720">
-            <a:normAutofit/>
+            <a:spAutoFit/>
           </a:bodyPr>
           <a:lstStyle/>
           <a:p>
@@ -3297,13 +3460,13 @@
       </p:sp>
       <p:sp>
         <p:nvSpPr>
-          <p:cNvPr id="4" name="TextBox 3"/>
+          <p:cNvPr id="5" name="TextBox 4"/>
           <p:cNvSpPr txBox="1"/>
           <p:nvPr/>
         </p:nvSpPr>
         <p:spPr>
           <a:xfrm>
-            <a:off x="914400" y="4754880"/>
+            <a:off x="914400" y="5029200"/>
             <a:ext cx="10332720" cy="457200"/>
           </a:xfrm>
           <a:prstGeom prst="rect">
@@ -3313,7 +3476,7 @@
         </p:spPr>
         <p:txBody>
           <a:bodyPr wrap="square" anchor="t" lIns="45720" rIns="45720">
-            <a:normAutofit/>
+            <a:spAutoFit/>
           </a:bodyPr>
           <a:lstStyle/>
           <a:p>
@@ -3361,7 +3524,74 @@
       <p:grpSpPr/>
       <p:sp>
         <p:nvSpPr>
-          <p:cNvPr id="2" name="TextBox 1"/>
+          <p:cNvPr id="2" name="Rectangle 1"/>
+          <p:cNvSpPr/>
+          <p:nvPr/>
+        </p:nvSpPr>
+        <p:spPr>
+          <a:xfrm>
+            <a:off x="640080" y="1463040"/>
+            <a:ext cx="822960" cy="822960"/>
+          </a:xfrm>
+          <a:noFill/>
+          <a:ln w="19050">
+            <a:solidFill>
+              <a:srgbClr val="D4A060"/>
+            </a:solidFill>
+          </a:ln>
+          <a:effectLst/>
+          <a:custGeom>
+            <a:pathLst>
+              <a:path w="100000" h="100000">
+                <a:moveTo>
+                  <a:pt x="24000" y="24000"/>
+                </a:moveTo>
+                <a:lnTo>
+                  <a:pt x="24000" y="56000"/>
+                </a:lnTo>
+                <a:lnTo>
+                  <a:pt x="44000" y="56000"/>
+                </a:lnTo>
+              </a:path>
+              <a:path w="100000" h="100000">
+                <a:moveTo>
+                  <a:pt x="56000" y="24000"/>
+                </a:moveTo>
+                <a:lnTo>
+                  <a:pt x="56000" y="56000"/>
+                </a:lnTo>
+                <a:lnTo>
+                  <a:pt x="76000" y="56000"/>
+                </a:lnTo>
+              </a:path>
+            </a:pathLst>
+          </a:custGeom>
+        </p:spPr>
+        <p:style>
+          <a:lnRef idx="1">
+            <a:schemeClr val="accent1"/>
+          </a:lnRef>
+          <a:fillRef idx="3">
+            <a:schemeClr val="accent1"/>
+          </a:fillRef>
+          <a:effectRef idx="2">
+            <a:schemeClr val="accent1"/>
+          </a:effectRef>
+          <a:fontRef idx="minor">
+            <a:schemeClr val="lt1"/>
+          </a:fontRef>
+        </p:style>
+        <p:txBody>
+          <a:bodyPr rtlCol="0" anchor="ctr"/>
+          <a:lstStyle/>
+          <a:p>
+            <a:pPr algn="ctr"/>
+          </a:p>
+        </p:txBody>
+      </p:sp>
+      <p:sp>
+        <p:nvSpPr>
+          <p:cNvPr id="3" name="TextBox 2"/>
           <p:cNvSpPr txBox="1"/>
           <p:nvPr/>
         </p:nvSpPr>
@@ -3377,13 +3607,13 @@
         </p:spPr>
         <p:txBody>
           <a:bodyPr wrap="square" anchor="t" lIns="45720" rIns="45720">
-            <a:normAutofit/>
+            <a:spAutoFit/>
           </a:bodyPr>
           <a:lstStyle/>
           <a:p>
             <a:pPr algn="l"/>
             <a:r>
-              <a:rPr sz="12000" b="1" i="0">
+              <a:rPr sz="8600" b="1" i="0">
                 <a:solidFill>
                   <a:srgbClr val="D4A060"/>
                 </a:solidFill>
@@ -3396,7 +3626,7 @@
       </p:sp>
       <p:sp>
         <p:nvSpPr>
-          <p:cNvPr id="3" name="TextBox 2"/>
+          <p:cNvPr id="4" name="TextBox 3"/>
           <p:cNvSpPr txBox="1"/>
           <p:nvPr/>
         </p:nvSpPr>
@@ -3412,7 +3642,7 @@
         </p:spPr>
         <p:txBody>
           <a:bodyPr wrap="square" anchor="ctr" lIns="45720" rIns="45720">
-            <a:normAutofit/>
+            <a:spAutoFit/>
           </a:bodyPr>
           <a:lstStyle/>
           <a:p>
@@ -3431,7 +3661,7 @@
       </p:sp>
       <p:sp>
         <p:nvSpPr>
-          <p:cNvPr id="4" name="TextBox 3"/>
+          <p:cNvPr id="5" name="TextBox 4"/>
           <p:cNvSpPr txBox="1"/>
           <p:nvPr/>
         </p:nvSpPr>
@@ -3447,7 +3677,7 @@
         </p:spPr>
         <p:txBody>
           <a:bodyPr wrap="square" anchor="t" lIns="45720" rIns="45720">
-            <a:normAutofit/>
+            <a:spAutoFit/>
           </a:bodyPr>
           <a:lstStyle/>
           <a:p>
@@ -3466,7 +3696,7 @@
       </p:sp>
       <p:sp>
         <p:nvSpPr>
-          <p:cNvPr id="5" name="TextBox 4"/>
+          <p:cNvPr id="6" name="TextBox 5"/>
           <p:cNvSpPr txBox="1"/>
           <p:nvPr/>
         </p:nvSpPr>
@@ -3482,7 +3712,7 @@
         </p:spPr>
         <p:txBody>
           <a:bodyPr wrap="square" anchor="t" lIns="45720" rIns="45720">
-            <a:normAutofit/>
+            <a:spAutoFit/>
           </a:bodyPr>
           <a:lstStyle/>
           <a:p>
@@ -3501,7 +3731,7 @@
       </p:sp>
       <p:sp>
         <p:nvSpPr>
-          <p:cNvPr id="6" name="TextBox 5"/>
+          <p:cNvPr id="7" name="TextBox 6"/>
           <p:cNvSpPr txBox="1"/>
           <p:nvPr/>
         </p:nvSpPr>
@@ -3517,7 +3747,7 @@
         </p:spPr>
         <p:txBody>
           <a:bodyPr wrap="square" anchor="t" lIns="45720" rIns="45720">
-            <a:normAutofit/>
+            <a:spAutoFit/>
           </a:bodyPr>
           <a:lstStyle/>
           <a:p>
@@ -3565,14 +3795,148 @@
       <p:grpSpPr/>
       <p:sp>
         <p:nvSpPr>
-          <p:cNvPr id="2" name="TextBox 1"/>
+          <p:cNvPr id="2" name="Rectangle 1"/>
+          <p:cNvSpPr/>
+          <p:nvPr/>
+        </p:nvSpPr>
+        <p:spPr>
+          <a:xfrm>
+            <a:off x="502920" y="384048"/>
+            <a:ext cx="457200" cy="457200"/>
+          </a:xfrm>
+          <a:noFill/>
+          <a:ln w="19050">
+            <a:solidFill>
+              <a:srgbClr val="D4A060"/>
+            </a:solidFill>
+          </a:ln>
+          <a:effectLst/>
+          <a:custGeom>
+            <a:pathLst>
+              <a:path w="100000" h="100000">
+                <a:moveTo>
+                  <a:pt x="86000" y="50000"/>
+                </a:moveTo>
+                <a:lnTo>
+                  <a:pt x="84773" y="59317"/>
+                </a:lnTo>
+                <a:lnTo>
+                  <a:pt x="81176" y="68000"/>
+                </a:lnTo>
+                <a:lnTo>
+                  <a:pt x="75455" y="75455"/>
+                </a:lnTo>
+                <a:lnTo>
+                  <a:pt x="68000" y="81176"/>
+                </a:lnTo>
+                <a:lnTo>
+                  <a:pt x="59317" y="84773"/>
+                </a:lnTo>
+                <a:lnTo>
+                  <a:pt x="50000" y="86000"/>
+                </a:lnTo>
+                <a:lnTo>
+                  <a:pt x="40682" y="84773"/>
+                </a:lnTo>
+                <a:lnTo>
+                  <a:pt x="32000" y="81176"/>
+                </a:lnTo>
+                <a:lnTo>
+                  <a:pt x="24544" y="75455"/>
+                </a:lnTo>
+                <a:lnTo>
+                  <a:pt x="18823" y="68000"/>
+                </a:lnTo>
+                <a:lnTo>
+                  <a:pt x="15226" y="59317"/>
+                </a:lnTo>
+                <a:lnTo>
+                  <a:pt x="14000" y="50000"/>
+                </a:lnTo>
+                <a:lnTo>
+                  <a:pt x="15226" y="40682"/>
+                </a:lnTo>
+                <a:lnTo>
+                  <a:pt x="18823" y="32000"/>
+                </a:lnTo>
+                <a:lnTo>
+                  <a:pt x="24544" y="24544"/>
+                </a:lnTo>
+                <a:lnTo>
+                  <a:pt x="31999" y="18823"/>
+                </a:lnTo>
+                <a:lnTo>
+                  <a:pt x="40682" y="15226"/>
+                </a:lnTo>
+                <a:lnTo>
+                  <a:pt x="49999" y="14000"/>
+                </a:lnTo>
+                <a:lnTo>
+                  <a:pt x="59317" y="15226"/>
+                </a:lnTo>
+                <a:lnTo>
+                  <a:pt x="68000" y="18823"/>
+                </a:lnTo>
+                <a:lnTo>
+                  <a:pt x="75455" y="24544"/>
+                </a:lnTo>
+                <a:lnTo>
+                  <a:pt x="81176" y="31999"/>
+                </a:lnTo>
+                <a:lnTo>
+                  <a:pt x="84773" y="40682"/>
+                </a:lnTo>
+                <a:lnTo>
+                  <a:pt x="86000" y="50000"/>
+                </a:lnTo>
+                <a:close/>
+              </a:path>
+              <a:path w="100000" h="100000">
+                <a:moveTo>
+                  <a:pt x="32000" y="52000"/>
+                </a:moveTo>
+                <a:lnTo>
+                  <a:pt x="46000" y="66000"/>
+                </a:lnTo>
+                <a:lnTo>
+                  <a:pt x="70000" y="36000"/>
+                </a:lnTo>
+              </a:path>
+            </a:pathLst>
+          </a:custGeom>
+        </p:spPr>
+        <p:style>
+          <a:lnRef idx="1">
+            <a:schemeClr val="accent1"/>
+          </a:lnRef>
+          <a:fillRef idx="3">
+            <a:schemeClr val="accent1"/>
+          </a:fillRef>
+          <a:effectRef idx="2">
+            <a:schemeClr val="accent1"/>
+          </a:effectRef>
+          <a:fontRef idx="minor">
+            <a:schemeClr val="lt1"/>
+          </a:fontRef>
+        </p:style>
+        <p:txBody>
+          <a:bodyPr rtlCol="0" anchor="ctr"/>
+          <a:lstStyle/>
+          <a:p>
+            <a:pPr algn="ctr"/>
+          </a:p>
+        </p:txBody>
+      </p:sp>
+      <p:sp>
+        <p:nvSpPr>
+          <p:cNvPr id="3" name="TextBox 2"/>
           <p:cNvSpPr txBox="1"/>
           <p:nvPr/>
         </p:nvSpPr>
         <p:spPr>
           <a:xfrm>
-            <a:off x="548640" y="365760"/>
-            <a:ext cx="10515600" cy="640080"/>
+            <a:off x="1097280" y="365760"/>
+            <a:ext cx="10058400" cy="640080"/>
           </a:xfrm>
           <a:prstGeom prst="rect">
             <a:avLst/>
@@ -3581,7 +3945,7 @@
         </p:spPr>
         <p:txBody>
           <a:bodyPr wrap="square" anchor="t" lIns="45720" rIns="45720">
-            <a:normAutofit/>
+            <a:spAutoFit/>
           </a:bodyPr>
           <a:lstStyle/>
           <a:p>
@@ -3600,13 +3964,13 @@
       </p:sp>
       <p:sp>
         <p:nvSpPr>
-          <p:cNvPr id="3" name="Rectangle 2"/>
+          <p:cNvPr id="4" name="Rectangle 3"/>
           <p:cNvSpPr/>
           <p:nvPr/>
         </p:nvSpPr>
         <p:spPr>
           <a:xfrm>
-            <a:off x="548640" y="1024128"/>
+            <a:off x="1097280" y="1024128"/>
             <a:ext cx="2011680" cy="54864"/>
           </a:xfrm>
           <a:prstGeom prst="rect">
@@ -3644,7 +4008,7 @@
       </p:sp>
       <p:sp>
         <p:nvSpPr>
-          <p:cNvPr id="4" name="Rectangle 3"/>
+          <p:cNvPr id="5" name="Rectangle 4"/>
           <p:cNvSpPr/>
           <p:nvPr/>
         </p:nvSpPr>
@@ -3688,7 +4052,7 @@
       </p:sp>
       <p:sp>
         <p:nvSpPr>
-          <p:cNvPr id="5" name="TextBox 4"/>
+          <p:cNvPr id="6" name="TextBox 5"/>
           <p:cNvSpPr txBox="1"/>
           <p:nvPr/>
         </p:nvSpPr>
@@ -3704,7 +4068,7 @@
         </p:spPr>
         <p:txBody>
           <a:bodyPr wrap="square" anchor="t" lIns="45720" rIns="45720">
-            <a:normAutofit/>
+            <a:spAutoFit/>
           </a:bodyPr>
           <a:lstStyle/>
           <a:p>
@@ -3723,7 +4087,7 @@
       </p:sp>
       <p:sp>
         <p:nvSpPr>
-          <p:cNvPr id="6" name="Rectangle 5"/>
+          <p:cNvPr id="7" name="Rectangle 6"/>
           <p:cNvSpPr/>
           <p:nvPr/>
         </p:nvSpPr>
@@ -3767,7 +4131,7 @@
       </p:sp>
       <p:sp>
         <p:nvSpPr>
-          <p:cNvPr id="7" name="TextBox 6"/>
+          <p:cNvPr id="8" name="TextBox 7"/>
           <p:cNvSpPr txBox="1"/>
           <p:nvPr/>
         </p:nvSpPr>
@@ -3783,7 +4147,7 @@
         </p:spPr>
         <p:txBody>
           <a:bodyPr wrap="square" anchor="t" lIns="45720" rIns="45720">
-            <a:normAutofit/>
+            <a:spAutoFit/>
           </a:bodyPr>
           <a:lstStyle/>
           <a:p>
@@ -3802,7 +4166,7 @@
       </p:sp>
       <p:sp>
         <p:nvSpPr>
-          <p:cNvPr id="8" name="Rectangle 7"/>
+          <p:cNvPr id="9" name="Rectangle 8"/>
           <p:cNvSpPr/>
           <p:nvPr/>
         </p:nvSpPr>
@@ -3846,7 +4210,7 @@
       </p:sp>
       <p:sp>
         <p:nvSpPr>
-          <p:cNvPr id="9" name="TextBox 8"/>
+          <p:cNvPr id="10" name="TextBox 9"/>
           <p:cNvSpPr txBox="1"/>
           <p:nvPr/>
         </p:nvSpPr>
@@ -3862,7 +4226,7 @@
         </p:spPr>
         <p:txBody>
           <a:bodyPr wrap="square" anchor="t" lIns="45720" rIns="45720">
-            <a:normAutofit/>
+            <a:spAutoFit/>
           </a:bodyPr>
           <a:lstStyle/>
           <a:p>
@@ -3881,7 +4245,7 @@
       </p:sp>
       <p:sp>
         <p:nvSpPr>
-          <p:cNvPr id="10" name="Rectangle 9"/>
+          <p:cNvPr id="11" name="Rectangle 10"/>
           <p:cNvSpPr/>
           <p:nvPr/>
         </p:nvSpPr>
@@ -3925,7 +4289,7 @@
       </p:sp>
       <p:sp>
         <p:nvSpPr>
-          <p:cNvPr id="11" name="TextBox 10"/>
+          <p:cNvPr id="12" name="TextBox 11"/>
           <p:cNvSpPr txBox="1"/>
           <p:nvPr/>
         </p:nvSpPr>
@@ -3941,7 +4305,7 @@
         </p:spPr>
         <p:txBody>
           <a:bodyPr wrap="square" anchor="ctr" lIns="45720" rIns="45720">
-            <a:normAutofit/>
+            <a:spAutoFit/>
           </a:bodyPr>
           <a:lstStyle/>
           <a:p>
@@ -3960,7 +4324,7 @@
       </p:sp>
       <p:sp>
         <p:nvSpPr>
-          <p:cNvPr id="12" name="TextBox 11"/>
+          <p:cNvPr id="13" name="TextBox 12"/>
           <p:cNvSpPr txBox="1"/>
           <p:nvPr/>
         </p:nvSpPr>
@@ -3976,7 +4340,7 @@
         </p:spPr>
         <p:txBody>
           <a:bodyPr wrap="square" anchor="t" lIns="45720" rIns="45720">
-            <a:normAutofit/>
+            <a:spAutoFit/>
           </a:bodyPr>
           <a:lstStyle/>
           <a:p>
@@ -3995,7 +4359,7 @@
       </p:sp>
       <p:sp>
         <p:nvSpPr>
-          <p:cNvPr id="13" name="TextBox 12"/>
+          <p:cNvPr id="14" name="TextBox 13"/>
           <p:cNvSpPr txBox="1"/>
           <p:nvPr/>
         </p:nvSpPr>
@@ -4011,7 +4375,7 @@
         </p:spPr>
         <p:txBody>
           <a:bodyPr wrap="square" anchor="t" lIns="45720" rIns="45720">
-            <a:normAutofit/>
+            <a:spAutoFit/>
           </a:bodyPr>
           <a:lstStyle/>
           <a:p>
@@ -4059,13 +4423,87 @@
       <p:grpSpPr/>
       <p:sp>
         <p:nvSpPr>
-          <p:cNvPr id="2" name="TextBox 1"/>
+          <p:cNvPr id="2" name="Rectangle 1"/>
+          <p:cNvSpPr/>
+          <p:nvPr/>
+        </p:nvSpPr>
+        <p:spPr>
+          <a:xfrm>
+            <a:off x="5733288" y="1280160"/>
+            <a:ext cx="731520" cy="731520"/>
+          </a:xfrm>
+          <a:noFill/>
+          <a:ln w="19050">
+            <a:solidFill>
+              <a:srgbClr val="D4A060"/>
+            </a:solidFill>
+          </a:ln>
+          <a:effectLst/>
+          <a:custGeom>
+            <a:pathLst>
+              <a:path w="100000" h="100000">
+                <a:moveTo>
+                  <a:pt x="20000" y="30000"/>
+                </a:moveTo>
+                <a:lnTo>
+                  <a:pt x="80000" y="30000"/>
+                </a:lnTo>
+                <a:lnTo>
+                  <a:pt x="80000" y="70000"/>
+                </a:lnTo>
+                <a:lnTo>
+                  <a:pt x="20000" y="70000"/>
+                </a:lnTo>
+                <a:lnTo>
+                  <a:pt x="20000" y="30000"/>
+                </a:lnTo>
+                <a:close/>
+              </a:path>
+              <a:path w="100000" h="100000">
+                <a:moveTo>
+                  <a:pt x="20000" y="30000"/>
+                </a:moveTo>
+                <a:lnTo>
+                  <a:pt x="50000" y="52000"/>
+                </a:lnTo>
+                <a:lnTo>
+                  <a:pt x="80000" y="30000"/>
+                </a:lnTo>
+              </a:path>
+            </a:pathLst>
+          </a:custGeom>
+        </p:spPr>
+        <p:style>
+          <a:lnRef idx="1">
+            <a:schemeClr val="accent1"/>
+          </a:lnRef>
+          <a:fillRef idx="3">
+            <a:schemeClr val="accent1"/>
+          </a:fillRef>
+          <a:effectRef idx="2">
+            <a:schemeClr val="accent1"/>
+          </a:effectRef>
+          <a:fontRef idx="minor">
+            <a:schemeClr val="lt1"/>
+          </a:fontRef>
+        </p:style>
+        <p:txBody>
+          <a:bodyPr rtlCol="0" anchor="ctr"/>
+          <a:lstStyle/>
+          <a:p>
+            <a:pPr algn="ctr"/>
+          </a:p>
+        </p:txBody>
+      </p:sp>
+      <p:sp>
+        <p:nvSpPr>
+          <p:cNvPr id="3" name="TextBox 2"/>
           <p:cNvSpPr txBox="1"/>
           <p:nvPr/>
         </p:nvSpPr>
         <p:spPr>
           <a:xfrm>
-            <a:off x="914400" y="2011680"/>
+            <a:off x="914400" y="2194560"/>
             <a:ext cx="10332720" cy="914400"/>
           </a:xfrm>
           <a:prstGeom prst="rect">
@@ -4075,7 +4513,7 @@
         </p:spPr>
         <p:txBody>
           <a:bodyPr wrap="square" anchor="t" lIns="45720" rIns="45720">
-            <a:normAutofit/>
+            <a:spAutoFit/>
           </a:bodyPr>
           <a:lstStyle/>
           <a:p>
@@ -4094,13 +4532,13 @@
       </p:sp>
       <p:sp>
         <p:nvSpPr>
-          <p:cNvPr id="3" name="TextBox 2"/>
+          <p:cNvPr id="4" name="TextBox 3"/>
           <p:cNvSpPr txBox="1"/>
           <p:nvPr/>
         </p:nvSpPr>
         <p:spPr>
           <a:xfrm>
-            <a:off x="914400" y="3108960"/>
+            <a:off x="914400" y="3291840"/>
             <a:ext cx="10332720" cy="1371600"/>
           </a:xfrm>
           <a:prstGeom prst="rect">
@@ -4110,7 +4548,7 @@
         </p:spPr>
         <p:txBody>
           <a:bodyPr wrap="square" anchor="t" lIns="45720" rIns="45720">
-            <a:normAutofit/>
+            <a:spAutoFit/>
           </a:bodyPr>
           <a:lstStyle/>
           <a:p>
@@ -4129,7 +4567,7 @@
       </p:sp>
       <p:sp>
         <p:nvSpPr>
-          <p:cNvPr id="4" name="TextBox 3"/>
+          <p:cNvPr id="5" name="TextBox 4"/>
           <p:cNvSpPr txBox="1"/>
           <p:nvPr/>
         </p:nvSpPr>
@@ -4145,7 +4583,7 @@
         </p:spPr>
         <p:txBody>
           <a:bodyPr wrap="square" anchor="t" lIns="45720" rIns="45720">
-            <a:normAutofit/>
+            <a:spAutoFit/>
           </a:bodyPr>
           <a:lstStyle/>
           <a:p>
@@ -4164,7 +4602,7 @@
       </p:sp>
       <p:sp>
         <p:nvSpPr>
-          <p:cNvPr id="5" name="TextBox 4"/>
+          <p:cNvPr id="6" name="TextBox 5"/>
           <p:cNvSpPr txBox="1"/>
           <p:nvPr/>
         </p:nvSpPr>
@@ -4180,7 +4618,7 @@
         </p:spPr>
         <p:txBody>
           <a:bodyPr wrap="square" anchor="t" lIns="45720" rIns="45720">
-            <a:normAutofit/>
+            <a:spAutoFit/>
           </a:bodyPr>
           <a:lstStyle/>
           <a:p>
@@ -4228,14 +4666,317 @@
       <p:grpSpPr/>
       <p:sp>
         <p:nvSpPr>
-          <p:cNvPr id="2" name="TextBox 1"/>
+          <p:cNvPr id="2" name="Rectangle 1"/>
+          <p:cNvSpPr/>
+          <p:nvPr/>
+        </p:nvSpPr>
+        <p:spPr>
+          <a:xfrm>
+            <a:off x="502920" y="384048"/>
+            <a:ext cx="457200" cy="457200"/>
+          </a:xfrm>
+          <a:noFill/>
+          <a:ln w="19050">
+            <a:solidFill>
+              <a:srgbClr val="D4A060"/>
+            </a:solidFill>
+          </a:ln>
+          <a:effectLst/>
+          <a:custGeom>
+            <a:pathLst>
+              <a:path w="100000" h="100000">
+                <a:moveTo>
+                  <a:pt x="30000" y="30000"/>
+                </a:moveTo>
+                <a:lnTo>
+                  <a:pt x="76000" y="30000"/>
+                </a:lnTo>
+              </a:path>
+              <a:path w="100000" h="100000">
+                <a:moveTo>
+                  <a:pt x="30000" y="50000"/>
+                </a:moveTo>
+                <a:lnTo>
+                  <a:pt x="76000" y="50000"/>
+                </a:lnTo>
+              </a:path>
+              <a:path w="100000" h="100000">
+                <a:moveTo>
+                  <a:pt x="30000" y="70000"/>
+                </a:moveTo>
+                <a:lnTo>
+                  <a:pt x="76000" y="70000"/>
+                </a:lnTo>
+              </a:path>
+              <a:path w="100000" h="100000">
+                <a:moveTo>
+                  <a:pt x="24000" y="30000"/>
+                </a:moveTo>
+                <a:lnTo>
+                  <a:pt x="23863" y="31035"/>
+                </a:lnTo>
+                <a:lnTo>
+                  <a:pt x="23464" y="32000"/>
+                </a:lnTo>
+                <a:lnTo>
+                  <a:pt x="22828" y="32828"/>
+                </a:lnTo>
+                <a:lnTo>
+                  <a:pt x="22000" y="33464"/>
+                </a:lnTo>
+                <a:lnTo>
+                  <a:pt x="21035" y="33863"/>
+                </a:lnTo>
+                <a:lnTo>
+                  <a:pt x="20000" y="34000"/>
+                </a:lnTo>
+                <a:lnTo>
+                  <a:pt x="18964" y="33863"/>
+                </a:lnTo>
+                <a:lnTo>
+                  <a:pt x="18000" y="33464"/>
+                </a:lnTo>
+                <a:lnTo>
+                  <a:pt x="17171" y="32828"/>
+                </a:lnTo>
+                <a:lnTo>
+                  <a:pt x="16535" y="32000"/>
+                </a:lnTo>
+                <a:lnTo>
+                  <a:pt x="16136" y="31035"/>
+                </a:lnTo>
+                <a:lnTo>
+                  <a:pt x="16000" y="30000"/>
+                </a:lnTo>
+                <a:lnTo>
+                  <a:pt x="16136" y="28964"/>
+                </a:lnTo>
+                <a:lnTo>
+                  <a:pt x="16535" y="28000"/>
+                </a:lnTo>
+                <a:lnTo>
+                  <a:pt x="17171" y="27171"/>
+                </a:lnTo>
+                <a:lnTo>
+                  <a:pt x="18000" y="26535"/>
+                </a:lnTo>
+                <a:lnTo>
+                  <a:pt x="18964" y="26136"/>
+                </a:lnTo>
+                <a:lnTo>
+                  <a:pt x="20000" y="26000"/>
+                </a:lnTo>
+                <a:lnTo>
+                  <a:pt x="21035" y="26136"/>
+                </a:lnTo>
+                <a:lnTo>
+                  <a:pt x="22000" y="26535"/>
+                </a:lnTo>
+                <a:lnTo>
+                  <a:pt x="22828" y="27171"/>
+                </a:lnTo>
+                <a:lnTo>
+                  <a:pt x="23464" y="28000"/>
+                </a:lnTo>
+                <a:lnTo>
+                  <a:pt x="23863" y="28964"/>
+                </a:lnTo>
+                <a:lnTo>
+                  <a:pt x="24000" y="30000"/>
+                </a:lnTo>
+                <a:close/>
+              </a:path>
+              <a:path w="100000" h="100000">
+                <a:moveTo>
+                  <a:pt x="24000" y="50000"/>
+                </a:moveTo>
+                <a:lnTo>
+                  <a:pt x="23863" y="51035"/>
+                </a:lnTo>
+                <a:lnTo>
+                  <a:pt x="23464" y="52000"/>
+                </a:lnTo>
+                <a:lnTo>
+                  <a:pt x="22828" y="52828"/>
+                </a:lnTo>
+                <a:lnTo>
+                  <a:pt x="22000" y="53464"/>
+                </a:lnTo>
+                <a:lnTo>
+                  <a:pt x="21035" y="53863"/>
+                </a:lnTo>
+                <a:lnTo>
+                  <a:pt x="20000" y="54000"/>
+                </a:lnTo>
+                <a:lnTo>
+                  <a:pt x="18964" y="53863"/>
+                </a:lnTo>
+                <a:lnTo>
+                  <a:pt x="18000" y="53464"/>
+                </a:lnTo>
+                <a:lnTo>
+                  <a:pt x="17171" y="52828"/>
+                </a:lnTo>
+                <a:lnTo>
+                  <a:pt x="16535" y="52000"/>
+                </a:lnTo>
+                <a:lnTo>
+                  <a:pt x="16136" y="51035"/>
+                </a:lnTo>
+                <a:lnTo>
+                  <a:pt x="16000" y="50000"/>
+                </a:lnTo>
+                <a:lnTo>
+                  <a:pt x="16136" y="48964"/>
+                </a:lnTo>
+                <a:lnTo>
+                  <a:pt x="16535" y="48000"/>
+                </a:lnTo>
+                <a:lnTo>
+                  <a:pt x="17171" y="47171"/>
+                </a:lnTo>
+                <a:lnTo>
+                  <a:pt x="18000" y="46535"/>
+                </a:lnTo>
+                <a:lnTo>
+                  <a:pt x="18964" y="46136"/>
+                </a:lnTo>
+                <a:lnTo>
+                  <a:pt x="20000" y="46000"/>
+                </a:lnTo>
+                <a:lnTo>
+                  <a:pt x="21035" y="46136"/>
+                </a:lnTo>
+                <a:lnTo>
+                  <a:pt x="22000" y="46535"/>
+                </a:lnTo>
+                <a:lnTo>
+                  <a:pt x="22828" y="47171"/>
+                </a:lnTo>
+                <a:lnTo>
+                  <a:pt x="23464" y="48000"/>
+                </a:lnTo>
+                <a:lnTo>
+                  <a:pt x="23863" y="48964"/>
+                </a:lnTo>
+                <a:lnTo>
+                  <a:pt x="24000" y="50000"/>
+                </a:lnTo>
+                <a:close/>
+              </a:path>
+              <a:path w="100000" h="100000">
+                <a:moveTo>
+                  <a:pt x="24000" y="70000"/>
+                </a:moveTo>
+                <a:lnTo>
+                  <a:pt x="23863" y="71035"/>
+                </a:lnTo>
+                <a:lnTo>
+                  <a:pt x="23464" y="72000"/>
+                </a:lnTo>
+                <a:lnTo>
+                  <a:pt x="22828" y="72828"/>
+                </a:lnTo>
+                <a:lnTo>
+                  <a:pt x="22000" y="73464"/>
+                </a:lnTo>
+                <a:lnTo>
+                  <a:pt x="21035" y="73863"/>
+                </a:lnTo>
+                <a:lnTo>
+                  <a:pt x="20000" y="74000"/>
+                </a:lnTo>
+                <a:lnTo>
+                  <a:pt x="18964" y="73863"/>
+                </a:lnTo>
+                <a:lnTo>
+                  <a:pt x="18000" y="73464"/>
+                </a:lnTo>
+                <a:lnTo>
+                  <a:pt x="17171" y="72828"/>
+                </a:lnTo>
+                <a:lnTo>
+                  <a:pt x="16535" y="72000"/>
+                </a:lnTo>
+                <a:lnTo>
+                  <a:pt x="16136" y="71035"/>
+                </a:lnTo>
+                <a:lnTo>
+                  <a:pt x="16000" y="70000"/>
+                </a:lnTo>
+                <a:lnTo>
+                  <a:pt x="16136" y="68964"/>
+                </a:lnTo>
+                <a:lnTo>
+                  <a:pt x="16535" y="68000"/>
+                </a:lnTo>
+                <a:lnTo>
+                  <a:pt x="17171" y="67171"/>
+                </a:lnTo>
+                <a:lnTo>
+                  <a:pt x="18000" y="66535"/>
+                </a:lnTo>
+                <a:lnTo>
+                  <a:pt x="18964" y="66136"/>
+                </a:lnTo>
+                <a:lnTo>
+                  <a:pt x="20000" y="66000"/>
+                </a:lnTo>
+                <a:lnTo>
+                  <a:pt x="21035" y="66136"/>
+                </a:lnTo>
+                <a:lnTo>
+                  <a:pt x="22000" y="66535"/>
+                </a:lnTo>
+                <a:lnTo>
+                  <a:pt x="22828" y="67171"/>
+                </a:lnTo>
+                <a:lnTo>
+                  <a:pt x="23464" y="68000"/>
+                </a:lnTo>
+                <a:lnTo>
+                  <a:pt x="23863" y="68964"/>
+                </a:lnTo>
+                <a:lnTo>
+                  <a:pt x="24000" y="70000"/>
+                </a:lnTo>
+                <a:close/>
+              </a:path>
+            </a:pathLst>
+          </a:custGeom>
+        </p:spPr>
+        <p:style>
+          <a:lnRef idx="1">
+            <a:schemeClr val="accent1"/>
+          </a:lnRef>
+          <a:fillRef idx="3">
+            <a:schemeClr val="accent1"/>
+          </a:fillRef>
+          <a:effectRef idx="2">
+            <a:schemeClr val="accent1"/>
+          </a:effectRef>
+          <a:fontRef idx="minor">
+            <a:schemeClr val="lt1"/>
+          </a:fontRef>
+        </p:style>
+        <p:txBody>
+          <a:bodyPr rtlCol="0" anchor="ctr"/>
+          <a:lstStyle/>
+          <a:p>
+            <a:pPr algn="ctr"/>
+          </a:p>
+        </p:txBody>
+      </p:sp>
+      <p:sp>
+        <p:nvSpPr>
+          <p:cNvPr id="3" name="TextBox 2"/>
           <p:cNvSpPr txBox="1"/>
           <p:nvPr/>
         </p:nvSpPr>
         <p:spPr>
           <a:xfrm>
-            <a:off x="548640" y="365760"/>
-            <a:ext cx="10515600" cy="640080"/>
+            <a:off x="1097280" y="365760"/>
+            <a:ext cx="10058400" cy="640080"/>
           </a:xfrm>
           <a:prstGeom prst="rect">
             <a:avLst/>
@@ -4244,7 +4985,7 @@
         </p:spPr>
         <p:txBody>
           <a:bodyPr wrap="square" anchor="t" lIns="45720" rIns="45720">
-            <a:normAutofit/>
+            <a:spAutoFit/>
           </a:bodyPr>
           <a:lstStyle/>
           <a:p>
@@ -4263,13 +5004,13 @@
       </p:sp>
       <p:sp>
         <p:nvSpPr>
-          <p:cNvPr id="3" name="Rectangle 2"/>
+          <p:cNvPr id="4" name="Rectangle 3"/>
           <p:cNvSpPr/>
           <p:nvPr/>
         </p:nvSpPr>
         <p:spPr>
           <a:xfrm>
-            <a:off x="548640" y="1024128"/>
+            <a:off x="1097280" y="1024128"/>
             <a:ext cx="2011680" cy="54864"/>
           </a:xfrm>
           <a:prstGeom prst="rect">
@@ -4307,7 +5048,7 @@
       </p:sp>
       <p:sp>
         <p:nvSpPr>
-          <p:cNvPr id="4" name="TextBox 3"/>
+          <p:cNvPr id="5" name="TextBox 4"/>
           <p:cNvSpPr txBox="1"/>
           <p:nvPr/>
         </p:nvSpPr>
@@ -4323,7 +5064,7 @@
         </p:spPr>
         <p:txBody>
           <a:bodyPr wrap="square" anchor="t" lIns="45720" rIns="45720">
-            <a:normAutofit/>
+            <a:spAutoFit/>
           </a:bodyPr>
           <a:lstStyle/>
           <a:p>
@@ -4342,7 +5083,7 @@
       </p:sp>
       <p:sp>
         <p:nvSpPr>
-          <p:cNvPr id="5" name="TextBox 4"/>
+          <p:cNvPr id="6" name="TextBox 5"/>
           <p:cNvSpPr txBox="1"/>
           <p:nvPr/>
         </p:nvSpPr>
@@ -4358,7 +5099,7 @@
         </p:spPr>
         <p:txBody>
           <a:bodyPr wrap="square" anchor="t" lIns="45720" rIns="45720">
-            <a:normAutofit/>
+            <a:spAutoFit/>
           </a:bodyPr>
           <a:lstStyle/>
           <a:p>
@@ -4377,7 +5118,7 @@
       </p:sp>
       <p:sp>
         <p:nvSpPr>
-          <p:cNvPr id="6" name="Rectangle 5"/>
+          <p:cNvPr id="7" name="Rectangle 6"/>
           <p:cNvSpPr/>
           <p:nvPr/>
         </p:nvSpPr>
@@ -4421,7 +5162,7 @@
       </p:sp>
       <p:sp>
         <p:nvSpPr>
-          <p:cNvPr id="7" name="TextBox 6"/>
+          <p:cNvPr id="8" name="TextBox 7"/>
           <p:cNvSpPr txBox="1"/>
           <p:nvPr/>
         </p:nvSpPr>
@@ -4437,7 +5178,7 @@
         </p:spPr>
         <p:txBody>
           <a:bodyPr wrap="square" anchor="t" lIns="45720" rIns="45720">
-            <a:normAutofit/>
+            <a:spAutoFit/>
           </a:bodyPr>
           <a:lstStyle/>
           <a:p>
@@ -4456,7 +5197,7 @@
       </p:sp>
       <p:sp>
         <p:nvSpPr>
-          <p:cNvPr id="8" name="TextBox 7"/>
+          <p:cNvPr id="9" name="TextBox 8"/>
           <p:cNvSpPr txBox="1"/>
           <p:nvPr/>
         </p:nvSpPr>
@@ -4472,7 +5213,7 @@
         </p:spPr>
         <p:txBody>
           <a:bodyPr wrap="square" anchor="t" lIns="45720" rIns="45720">
-            <a:normAutofit/>
+            <a:spAutoFit/>
           </a:bodyPr>
           <a:lstStyle/>
           <a:p>
@@ -4491,7 +5232,7 @@
       </p:sp>
       <p:sp>
         <p:nvSpPr>
-          <p:cNvPr id="9" name="Rectangle 8"/>
+          <p:cNvPr id="10" name="Rectangle 9"/>
           <p:cNvSpPr/>
           <p:nvPr/>
         </p:nvSpPr>
@@ -4535,7 +5276,7 @@
       </p:sp>
       <p:sp>
         <p:nvSpPr>
-          <p:cNvPr id="10" name="TextBox 9"/>
+          <p:cNvPr id="11" name="TextBox 10"/>
           <p:cNvSpPr txBox="1"/>
           <p:nvPr/>
         </p:nvSpPr>
@@ -4551,7 +5292,7 @@
         </p:spPr>
         <p:txBody>
           <a:bodyPr wrap="square" anchor="t" lIns="45720" rIns="45720">
-            <a:normAutofit/>
+            <a:spAutoFit/>
           </a:bodyPr>
           <a:lstStyle/>
           <a:p>
@@ -4570,7 +5311,7 @@
       </p:sp>
       <p:sp>
         <p:nvSpPr>
-          <p:cNvPr id="11" name="TextBox 10"/>
+          <p:cNvPr id="12" name="TextBox 11"/>
           <p:cNvSpPr txBox="1"/>
           <p:nvPr/>
         </p:nvSpPr>
@@ -4586,7 +5327,7 @@
         </p:spPr>
         <p:txBody>
           <a:bodyPr wrap="square" anchor="t" lIns="45720" rIns="45720">
-            <a:normAutofit/>
+            <a:spAutoFit/>
           </a:bodyPr>
           <a:lstStyle/>
           <a:p>
@@ -4605,7 +5346,7 @@
       </p:sp>
       <p:sp>
         <p:nvSpPr>
-          <p:cNvPr id="12" name="Rectangle 11"/>
+          <p:cNvPr id="13" name="Rectangle 12"/>
           <p:cNvSpPr/>
           <p:nvPr/>
         </p:nvSpPr>
@@ -4649,7 +5390,7 @@
       </p:sp>
       <p:sp>
         <p:nvSpPr>
-          <p:cNvPr id="13" name="TextBox 12"/>
+          <p:cNvPr id="14" name="TextBox 13"/>
           <p:cNvSpPr txBox="1"/>
           <p:nvPr/>
         </p:nvSpPr>
@@ -4665,7 +5406,7 @@
         </p:spPr>
         <p:txBody>
           <a:bodyPr wrap="square" anchor="t" lIns="45720" rIns="45720">
-            <a:normAutofit/>
+            <a:spAutoFit/>
           </a:bodyPr>
           <a:lstStyle/>
           <a:p>
@@ -4684,7 +5425,7 @@
       </p:sp>
       <p:sp>
         <p:nvSpPr>
-          <p:cNvPr id="14" name="TextBox 13"/>
+          <p:cNvPr id="15" name="TextBox 14"/>
           <p:cNvSpPr txBox="1"/>
           <p:nvPr/>
         </p:nvSpPr>
@@ -4700,7 +5441,7 @@
         </p:spPr>
         <p:txBody>
           <a:bodyPr wrap="square" anchor="t" lIns="45720" rIns="45720">
-            <a:normAutofit/>
+            <a:spAutoFit/>
           </a:bodyPr>
           <a:lstStyle/>
           <a:p>
@@ -4719,7 +5460,7 @@
       </p:sp>
       <p:sp>
         <p:nvSpPr>
-          <p:cNvPr id="15" name="Rectangle 14"/>
+          <p:cNvPr id="16" name="Rectangle 15"/>
           <p:cNvSpPr/>
           <p:nvPr/>
         </p:nvSpPr>
@@ -4763,7 +5504,7 @@
       </p:sp>
       <p:sp>
         <p:nvSpPr>
-          <p:cNvPr id="16" name="TextBox 15"/>
+          <p:cNvPr id="17" name="TextBox 16"/>
           <p:cNvSpPr txBox="1"/>
           <p:nvPr/>
         </p:nvSpPr>
@@ -4779,7 +5520,7 @@
         </p:spPr>
         <p:txBody>
           <a:bodyPr wrap="square" anchor="t" lIns="45720" rIns="45720">
-            <a:normAutofit/>
+            <a:spAutoFit/>
           </a:bodyPr>
           <a:lstStyle/>
           <a:p>
@@ -4798,7 +5539,7 @@
       </p:sp>
       <p:sp>
         <p:nvSpPr>
-          <p:cNvPr id="17" name="TextBox 16"/>
+          <p:cNvPr id="18" name="TextBox 17"/>
           <p:cNvSpPr txBox="1"/>
           <p:nvPr/>
         </p:nvSpPr>
@@ -4814,7 +5555,7 @@
         </p:spPr>
         <p:txBody>
           <a:bodyPr wrap="square" anchor="t" lIns="45720" rIns="45720">
-            <a:normAutofit/>
+            <a:spAutoFit/>
           </a:bodyPr>
           <a:lstStyle/>
           <a:p>
@@ -4833,7 +5574,7 @@
       </p:sp>
       <p:sp>
         <p:nvSpPr>
-          <p:cNvPr id="18" name="Rectangle 17"/>
+          <p:cNvPr id="19" name="Rectangle 18"/>
           <p:cNvSpPr/>
           <p:nvPr/>
         </p:nvSpPr>
@@ -4877,7 +5618,7 @@
       </p:sp>
       <p:sp>
         <p:nvSpPr>
-          <p:cNvPr id="19" name="TextBox 18"/>
+          <p:cNvPr id="20" name="TextBox 19"/>
           <p:cNvSpPr txBox="1"/>
           <p:nvPr/>
         </p:nvSpPr>
@@ -4893,7 +5634,7 @@
         </p:spPr>
         <p:txBody>
           <a:bodyPr wrap="square" anchor="t" lIns="45720" rIns="45720">
-            <a:normAutofit/>
+            <a:spAutoFit/>
           </a:bodyPr>
           <a:lstStyle/>
           <a:p>
@@ -4912,7 +5653,7 @@
       </p:sp>
       <p:sp>
         <p:nvSpPr>
-          <p:cNvPr id="20" name="TextBox 19"/>
+          <p:cNvPr id="21" name="TextBox 20"/>
           <p:cNvSpPr txBox="1"/>
           <p:nvPr/>
         </p:nvSpPr>
@@ -4928,7 +5669,7 @@
         </p:spPr>
         <p:txBody>
           <a:bodyPr wrap="square" anchor="t" lIns="45720" rIns="45720">
-            <a:normAutofit/>
+            <a:spAutoFit/>
           </a:bodyPr>
           <a:lstStyle/>
           <a:p>
@@ -5064,14 +5805,80 @@
       </p:sp>
       <p:sp>
         <p:nvSpPr>
-          <p:cNvPr id="4" name="TextBox 3"/>
+          <p:cNvPr id="4" name="Rectangle 3"/>
+          <p:cNvSpPr/>
+          <p:nvPr/>
+        </p:nvSpPr>
+        <p:spPr>
+          <a:xfrm>
+            <a:off x="548640" y="2999232"/>
+            <a:ext cx="822960" cy="822960"/>
+          </a:xfrm>
+          <a:noFill/>
+          <a:ln w="19050">
+            <a:solidFill>
+              <a:srgbClr val="D4A060"/>
+            </a:solidFill>
+          </a:ln>
+          <a:effectLst/>
+          <a:custGeom>
+            <a:pathLst>
+              <a:path w="100000" h="100000">
+                <a:moveTo>
+                  <a:pt x="30000" y="18000"/>
+                </a:moveTo>
+                <a:lnTo>
+                  <a:pt x="70000" y="18000"/>
+                </a:lnTo>
+                <a:lnTo>
+                  <a:pt x="70000" y="82000"/>
+                </a:lnTo>
+                <a:lnTo>
+                  <a:pt x="50000" y="66000"/>
+                </a:lnTo>
+                <a:lnTo>
+                  <a:pt x="30000" y="82000"/>
+                </a:lnTo>
+                <a:lnTo>
+                  <a:pt x="30000" y="18000"/>
+                </a:lnTo>
+                <a:close/>
+              </a:path>
+            </a:pathLst>
+          </a:custGeom>
+        </p:spPr>
+        <p:style>
+          <a:lnRef idx="1">
+            <a:schemeClr val="accent1"/>
+          </a:lnRef>
+          <a:fillRef idx="3">
+            <a:schemeClr val="accent1"/>
+          </a:fillRef>
+          <a:effectRef idx="2">
+            <a:schemeClr val="accent1"/>
+          </a:effectRef>
+          <a:fontRef idx="minor">
+            <a:schemeClr val="lt1"/>
+          </a:fontRef>
+        </p:style>
+        <p:txBody>
+          <a:bodyPr rtlCol="0" anchor="ctr"/>
+          <a:lstStyle/>
+          <a:p>
+            <a:pPr algn="ctr"/>
+          </a:p>
+        </p:txBody>
+      </p:sp>
+      <p:sp>
+        <p:nvSpPr>
+          <p:cNvPr id="5" name="TextBox 4"/>
           <p:cNvSpPr txBox="1"/>
           <p:nvPr/>
         </p:nvSpPr>
         <p:spPr>
           <a:xfrm>
-            <a:off x="822960" y="2971800"/>
-            <a:ext cx="10515600" cy="914400"/>
+            <a:off x="1554480" y="2971800"/>
+            <a:ext cx="10058400" cy="914400"/>
           </a:xfrm>
           <a:prstGeom prst="rect">
             <a:avLst/>
@@ -5080,7 +5887,7 @@
         </p:spPr>
         <p:txBody>
           <a:bodyPr wrap="square" anchor="ctr" lIns="45720" rIns="45720">
-            <a:normAutofit/>
+            <a:spAutoFit/>
           </a:bodyPr>
           <a:lstStyle/>
           <a:p>
@@ -5099,14 +5906,14 @@
       </p:sp>
       <p:sp>
         <p:nvSpPr>
-          <p:cNvPr id="5" name="TextBox 4"/>
+          <p:cNvPr id="6" name="TextBox 5"/>
           <p:cNvSpPr txBox="1"/>
           <p:nvPr/>
         </p:nvSpPr>
         <p:spPr>
           <a:xfrm>
-            <a:off x="822960" y="3886200"/>
-            <a:ext cx="10515600" cy="457200"/>
+            <a:off x="1554480" y="3886200"/>
+            <a:ext cx="10058400" cy="457200"/>
           </a:xfrm>
           <a:prstGeom prst="rect">
             <a:avLst/>
@@ -5115,7 +5922,7 @@
         </p:spPr>
         <p:txBody>
           <a:bodyPr wrap="square" anchor="t" lIns="45720" rIns="45720">
-            <a:normAutofit/>
+            <a:spAutoFit/>
           </a:bodyPr>
           <a:lstStyle/>
           <a:p>
@@ -5163,14 +5970,317 @@
       <p:grpSpPr/>
       <p:sp>
         <p:nvSpPr>
-          <p:cNvPr id="2" name="TextBox 1"/>
+          <p:cNvPr id="2" name="Rectangle 1"/>
+          <p:cNvSpPr/>
+          <p:nvPr/>
+        </p:nvSpPr>
+        <p:spPr>
+          <a:xfrm>
+            <a:off x="502920" y="384048"/>
+            <a:ext cx="457200" cy="457200"/>
+          </a:xfrm>
+          <a:noFill/>
+          <a:ln w="19050">
+            <a:solidFill>
+              <a:srgbClr val="D4A060"/>
+            </a:solidFill>
+          </a:ln>
+          <a:effectLst/>
+          <a:custGeom>
+            <a:pathLst>
+              <a:path w="100000" h="100000">
+                <a:moveTo>
+                  <a:pt x="30000" y="30000"/>
+                </a:moveTo>
+                <a:lnTo>
+                  <a:pt x="76000" y="30000"/>
+                </a:lnTo>
+              </a:path>
+              <a:path w="100000" h="100000">
+                <a:moveTo>
+                  <a:pt x="30000" y="50000"/>
+                </a:moveTo>
+                <a:lnTo>
+                  <a:pt x="76000" y="50000"/>
+                </a:lnTo>
+              </a:path>
+              <a:path w="100000" h="100000">
+                <a:moveTo>
+                  <a:pt x="30000" y="70000"/>
+                </a:moveTo>
+                <a:lnTo>
+                  <a:pt x="76000" y="70000"/>
+                </a:lnTo>
+              </a:path>
+              <a:path w="100000" h="100000">
+                <a:moveTo>
+                  <a:pt x="24000" y="30000"/>
+                </a:moveTo>
+                <a:lnTo>
+                  <a:pt x="23863" y="31035"/>
+                </a:lnTo>
+                <a:lnTo>
+                  <a:pt x="23464" y="32000"/>
+                </a:lnTo>
+                <a:lnTo>
+                  <a:pt x="22828" y="32828"/>
+                </a:lnTo>
+                <a:lnTo>
+                  <a:pt x="22000" y="33464"/>
+                </a:lnTo>
+                <a:lnTo>
+                  <a:pt x="21035" y="33863"/>
+                </a:lnTo>
+                <a:lnTo>
+                  <a:pt x="20000" y="34000"/>
+                </a:lnTo>
+                <a:lnTo>
+                  <a:pt x="18964" y="33863"/>
+                </a:lnTo>
+                <a:lnTo>
+                  <a:pt x="18000" y="33464"/>
+                </a:lnTo>
+                <a:lnTo>
+                  <a:pt x="17171" y="32828"/>
+                </a:lnTo>
+                <a:lnTo>
+                  <a:pt x="16535" y="32000"/>
+                </a:lnTo>
+                <a:lnTo>
+                  <a:pt x="16136" y="31035"/>
+                </a:lnTo>
+                <a:lnTo>
+                  <a:pt x="16000" y="30000"/>
+                </a:lnTo>
+                <a:lnTo>
+                  <a:pt x="16136" y="28964"/>
+                </a:lnTo>
+                <a:lnTo>
+                  <a:pt x="16535" y="28000"/>
+                </a:lnTo>
+                <a:lnTo>
+                  <a:pt x="17171" y="27171"/>
+                </a:lnTo>
+                <a:lnTo>
+                  <a:pt x="18000" y="26535"/>
+                </a:lnTo>
+                <a:lnTo>
+                  <a:pt x="18964" y="26136"/>
+                </a:lnTo>
+                <a:lnTo>
+                  <a:pt x="20000" y="26000"/>
+                </a:lnTo>
+                <a:lnTo>
+                  <a:pt x="21035" y="26136"/>
+                </a:lnTo>
+                <a:lnTo>
+                  <a:pt x="22000" y="26535"/>
+                </a:lnTo>
+                <a:lnTo>
+                  <a:pt x="22828" y="27171"/>
+                </a:lnTo>
+                <a:lnTo>
+                  <a:pt x="23464" y="28000"/>
+                </a:lnTo>
+                <a:lnTo>
+                  <a:pt x="23863" y="28964"/>
+                </a:lnTo>
+                <a:lnTo>
+                  <a:pt x="24000" y="30000"/>
+                </a:lnTo>
+                <a:close/>
+              </a:path>
+              <a:path w="100000" h="100000">
+                <a:moveTo>
+                  <a:pt x="24000" y="50000"/>
+                </a:moveTo>
+                <a:lnTo>
+                  <a:pt x="23863" y="51035"/>
+                </a:lnTo>
+                <a:lnTo>
+                  <a:pt x="23464" y="52000"/>
+                </a:lnTo>
+                <a:lnTo>
+                  <a:pt x="22828" y="52828"/>
+                </a:lnTo>
+                <a:lnTo>
+                  <a:pt x="22000" y="53464"/>
+                </a:lnTo>
+                <a:lnTo>
+                  <a:pt x="21035" y="53863"/>
+                </a:lnTo>
+                <a:lnTo>
+                  <a:pt x="20000" y="54000"/>
+                </a:lnTo>
+                <a:lnTo>
+                  <a:pt x="18964" y="53863"/>
+                </a:lnTo>
+                <a:lnTo>
+                  <a:pt x="18000" y="53464"/>
+                </a:lnTo>
+                <a:lnTo>
+                  <a:pt x="17171" y="52828"/>
+                </a:lnTo>
+                <a:lnTo>
+                  <a:pt x="16535" y="52000"/>
+                </a:lnTo>
+                <a:lnTo>
+                  <a:pt x="16136" y="51035"/>
+                </a:lnTo>
+                <a:lnTo>
+                  <a:pt x="16000" y="50000"/>
+                </a:lnTo>
+                <a:lnTo>
+                  <a:pt x="16136" y="48964"/>
+                </a:lnTo>
+                <a:lnTo>
+                  <a:pt x="16535" y="48000"/>
+                </a:lnTo>
+                <a:lnTo>
+                  <a:pt x="17171" y="47171"/>
+                </a:lnTo>
+                <a:lnTo>
+                  <a:pt x="18000" y="46535"/>
+                </a:lnTo>
+                <a:lnTo>
+                  <a:pt x="18964" y="46136"/>
+                </a:lnTo>
+                <a:lnTo>
+                  <a:pt x="20000" y="46000"/>
+                </a:lnTo>
+                <a:lnTo>
+                  <a:pt x="21035" y="46136"/>
+                </a:lnTo>
+                <a:lnTo>
+                  <a:pt x="22000" y="46535"/>
+                </a:lnTo>
+                <a:lnTo>
+                  <a:pt x="22828" y="47171"/>
+                </a:lnTo>
+                <a:lnTo>
+                  <a:pt x="23464" y="48000"/>
+                </a:lnTo>
+                <a:lnTo>
+                  <a:pt x="23863" y="48964"/>
+                </a:lnTo>
+                <a:lnTo>
+                  <a:pt x="24000" y="50000"/>
+                </a:lnTo>
+                <a:close/>
+              </a:path>
+              <a:path w="100000" h="100000">
+                <a:moveTo>
+                  <a:pt x="24000" y="70000"/>
+                </a:moveTo>
+                <a:lnTo>
+                  <a:pt x="23863" y="71035"/>
+                </a:lnTo>
+                <a:lnTo>
+                  <a:pt x="23464" y="72000"/>
+                </a:lnTo>
+                <a:lnTo>
+                  <a:pt x="22828" y="72828"/>
+                </a:lnTo>
+                <a:lnTo>
+                  <a:pt x="22000" y="73464"/>
+                </a:lnTo>
+                <a:lnTo>
+                  <a:pt x="21035" y="73863"/>
+                </a:lnTo>
+                <a:lnTo>
+                  <a:pt x="20000" y="74000"/>
+                </a:lnTo>
+                <a:lnTo>
+                  <a:pt x="18964" y="73863"/>
+                </a:lnTo>
+                <a:lnTo>
+                  <a:pt x="18000" y="73464"/>
+                </a:lnTo>
+                <a:lnTo>
+                  <a:pt x="17171" y="72828"/>
+                </a:lnTo>
+                <a:lnTo>
+                  <a:pt x="16535" y="72000"/>
+                </a:lnTo>
+                <a:lnTo>
+                  <a:pt x="16136" y="71035"/>
+                </a:lnTo>
+                <a:lnTo>
+                  <a:pt x="16000" y="70000"/>
+                </a:lnTo>
+                <a:lnTo>
+                  <a:pt x="16136" y="68964"/>
+                </a:lnTo>
+                <a:lnTo>
+                  <a:pt x="16535" y="68000"/>
+                </a:lnTo>
+                <a:lnTo>
+                  <a:pt x="17171" y="67171"/>
+                </a:lnTo>
+                <a:lnTo>
+                  <a:pt x="18000" y="66535"/>
+                </a:lnTo>
+                <a:lnTo>
+                  <a:pt x="18964" y="66136"/>
+                </a:lnTo>
+                <a:lnTo>
+                  <a:pt x="20000" y="66000"/>
+                </a:lnTo>
+                <a:lnTo>
+                  <a:pt x="21035" y="66136"/>
+                </a:lnTo>
+                <a:lnTo>
+                  <a:pt x="22000" y="66535"/>
+                </a:lnTo>
+                <a:lnTo>
+                  <a:pt x="22828" y="67171"/>
+                </a:lnTo>
+                <a:lnTo>
+                  <a:pt x="23464" y="68000"/>
+                </a:lnTo>
+                <a:lnTo>
+                  <a:pt x="23863" y="68964"/>
+                </a:lnTo>
+                <a:lnTo>
+                  <a:pt x="24000" y="70000"/>
+                </a:lnTo>
+                <a:close/>
+              </a:path>
+            </a:pathLst>
+          </a:custGeom>
+        </p:spPr>
+        <p:style>
+          <a:lnRef idx="1">
+            <a:schemeClr val="accent1"/>
+          </a:lnRef>
+          <a:fillRef idx="3">
+            <a:schemeClr val="accent1"/>
+          </a:fillRef>
+          <a:effectRef idx="2">
+            <a:schemeClr val="accent1"/>
+          </a:effectRef>
+          <a:fontRef idx="minor">
+            <a:schemeClr val="lt1"/>
+          </a:fontRef>
+        </p:style>
+        <p:txBody>
+          <a:bodyPr rtlCol="0" anchor="ctr"/>
+          <a:lstStyle/>
+          <a:p>
+            <a:pPr algn="ctr"/>
+          </a:p>
+        </p:txBody>
+      </p:sp>
+      <p:sp>
+        <p:nvSpPr>
+          <p:cNvPr id="3" name="TextBox 2"/>
           <p:cNvSpPr txBox="1"/>
           <p:nvPr/>
         </p:nvSpPr>
         <p:spPr>
           <a:xfrm>
-            <a:off x="548640" y="365760"/>
-            <a:ext cx="10515600" cy="640080"/>
+            <a:off x="1097280" y="365760"/>
+            <a:ext cx="10058400" cy="640080"/>
           </a:xfrm>
           <a:prstGeom prst="rect">
             <a:avLst/>
@@ -5179,7 +6289,7 @@
         </p:spPr>
         <p:txBody>
           <a:bodyPr wrap="square" anchor="t" lIns="45720" rIns="45720">
-            <a:normAutofit/>
+            <a:spAutoFit/>
           </a:bodyPr>
           <a:lstStyle/>
           <a:p>
@@ -5198,13 +6308,13 @@
       </p:sp>
       <p:sp>
         <p:nvSpPr>
-          <p:cNvPr id="3" name="Rectangle 2"/>
+          <p:cNvPr id="4" name="Rectangle 3"/>
           <p:cNvSpPr/>
           <p:nvPr/>
         </p:nvSpPr>
         <p:spPr>
           <a:xfrm>
-            <a:off x="548640" y="1024128"/>
+            <a:off x="1097280" y="1024128"/>
             <a:ext cx="2011680" cy="54864"/>
           </a:xfrm>
           <a:prstGeom prst="rect">
@@ -5242,7 +6352,7 @@
       </p:sp>
       <p:sp>
         <p:nvSpPr>
-          <p:cNvPr id="4" name="Rectangle 3"/>
+          <p:cNvPr id="5" name="Rectangle 4"/>
           <p:cNvSpPr/>
           <p:nvPr/>
         </p:nvSpPr>
@@ -5286,7 +6396,7 @@
       </p:sp>
       <p:sp>
         <p:nvSpPr>
-          <p:cNvPr id="5" name="TextBox 4"/>
+          <p:cNvPr id="6" name="TextBox 5"/>
           <p:cNvSpPr txBox="1"/>
           <p:nvPr/>
         </p:nvSpPr>
@@ -5302,7 +6412,7 @@
         </p:spPr>
         <p:txBody>
           <a:bodyPr wrap="square" anchor="t" lIns="45720" rIns="45720">
-            <a:normAutofit/>
+            <a:spAutoFit/>
           </a:bodyPr>
           <a:lstStyle/>
           <a:p>
@@ -5321,7 +6431,7 @@
       </p:sp>
       <p:sp>
         <p:nvSpPr>
-          <p:cNvPr id="6" name="TextBox 5"/>
+          <p:cNvPr id="7" name="TextBox 6"/>
           <p:cNvSpPr txBox="1"/>
           <p:nvPr/>
         </p:nvSpPr>
@@ -5337,7 +6447,7 @@
         </p:spPr>
         <p:txBody>
           <a:bodyPr wrap="square" anchor="t" lIns="45720" rIns="45720">
-            <a:normAutofit/>
+            <a:spAutoFit/>
           </a:bodyPr>
           <a:lstStyle/>
           <a:p>
@@ -5356,7 +6466,7 @@
       </p:sp>
       <p:sp>
         <p:nvSpPr>
-          <p:cNvPr id="7" name="Rectangle 6"/>
+          <p:cNvPr id="8" name="Rectangle 7"/>
           <p:cNvSpPr/>
           <p:nvPr/>
         </p:nvSpPr>
@@ -5400,7 +6510,7 @@
       </p:sp>
       <p:sp>
         <p:nvSpPr>
-          <p:cNvPr id="8" name="TextBox 7"/>
+          <p:cNvPr id="9" name="TextBox 8"/>
           <p:cNvSpPr txBox="1"/>
           <p:nvPr/>
         </p:nvSpPr>
@@ -5416,7 +6526,7 @@
         </p:spPr>
         <p:txBody>
           <a:bodyPr wrap="square" anchor="t" lIns="45720" rIns="45720">
-            <a:normAutofit/>
+            <a:spAutoFit/>
           </a:bodyPr>
           <a:lstStyle/>
           <a:p>
@@ -5435,7 +6545,7 @@
       </p:sp>
       <p:sp>
         <p:nvSpPr>
-          <p:cNvPr id="9" name="TextBox 8"/>
+          <p:cNvPr id="10" name="TextBox 9"/>
           <p:cNvSpPr txBox="1"/>
           <p:nvPr/>
         </p:nvSpPr>
@@ -5451,7 +6561,7 @@
         </p:spPr>
         <p:txBody>
           <a:bodyPr wrap="square" anchor="t" lIns="45720" rIns="45720">
-            <a:normAutofit/>
+            <a:spAutoFit/>
           </a:bodyPr>
           <a:lstStyle/>
           <a:p>
@@ -5470,7 +6580,7 @@
       </p:sp>
       <p:sp>
         <p:nvSpPr>
-          <p:cNvPr id="10" name="Rectangle 9"/>
+          <p:cNvPr id="11" name="Rectangle 10"/>
           <p:cNvSpPr/>
           <p:nvPr/>
         </p:nvSpPr>
@@ -5514,7 +6624,7 @@
       </p:sp>
       <p:sp>
         <p:nvSpPr>
-          <p:cNvPr id="11" name="TextBox 10"/>
+          <p:cNvPr id="12" name="TextBox 11"/>
           <p:cNvSpPr txBox="1"/>
           <p:nvPr/>
         </p:nvSpPr>
@@ -5530,7 +6640,7 @@
         </p:spPr>
         <p:txBody>
           <a:bodyPr wrap="square" anchor="t" lIns="45720" rIns="45720">
-            <a:normAutofit/>
+            <a:spAutoFit/>
           </a:bodyPr>
           <a:lstStyle/>
           <a:p>
@@ -5549,7 +6659,7 @@
       </p:sp>
       <p:sp>
         <p:nvSpPr>
-          <p:cNvPr id="12" name="TextBox 11"/>
+          <p:cNvPr id="13" name="TextBox 12"/>
           <p:cNvSpPr txBox="1"/>
           <p:nvPr/>
         </p:nvSpPr>
@@ -5565,7 +6675,7 @@
         </p:spPr>
         <p:txBody>
           <a:bodyPr wrap="square" anchor="t" lIns="45720" rIns="45720">
-            <a:normAutofit/>
+            <a:spAutoFit/>
           </a:bodyPr>
           <a:lstStyle/>
           <a:p>
@@ -5584,7 +6694,7 @@
       </p:sp>
       <p:sp>
         <p:nvSpPr>
-          <p:cNvPr id="13" name="TextBox 12"/>
+          <p:cNvPr id="14" name="TextBox 13"/>
           <p:cNvSpPr txBox="1"/>
           <p:nvPr/>
         </p:nvSpPr>
@@ -5600,7 +6710,7 @@
         </p:spPr>
         <p:txBody>
           <a:bodyPr wrap="square" anchor="t" lIns="45720" rIns="45720">
-            <a:normAutofit/>
+            <a:spAutoFit/>
           </a:bodyPr>
           <a:lstStyle/>
           <a:p>
@@ -5619,7 +6729,7 @@
       </p:sp>
       <p:sp>
         <p:nvSpPr>
-          <p:cNvPr id="14" name="TextBox 13"/>
+          <p:cNvPr id="15" name="TextBox 14"/>
           <p:cNvSpPr txBox="1"/>
           <p:nvPr/>
         </p:nvSpPr>
@@ -5635,7 +6745,7 @@
         </p:spPr>
         <p:txBody>
           <a:bodyPr wrap="square" anchor="t" lIns="45720" rIns="45720">
-            <a:normAutofit/>
+            <a:spAutoFit/>
           </a:bodyPr>
           <a:lstStyle/>
           <a:p>
@@ -5683,14 +6793,107 @@
       <p:grpSpPr/>
       <p:sp>
         <p:nvSpPr>
-          <p:cNvPr id="2" name="TextBox 1"/>
+          <p:cNvPr id="2" name="Rectangle 1"/>
+          <p:cNvSpPr/>
+          <p:nvPr/>
+        </p:nvSpPr>
+        <p:spPr>
+          <a:xfrm>
+            <a:off x="502920" y="384048"/>
+            <a:ext cx="457200" cy="457200"/>
+          </a:xfrm>
+          <a:noFill/>
+          <a:ln w="19050">
+            <a:solidFill>
+              <a:srgbClr val="D4A060"/>
+            </a:solidFill>
+          </a:ln>
+          <a:effectLst/>
+          <a:custGeom>
+            <a:pathLst>
+              <a:path w="100000" h="100000">
+                <a:moveTo>
+                  <a:pt x="20000" y="74000"/>
+                </a:moveTo>
+                <a:lnTo>
+                  <a:pt x="20000" y="26000"/>
+                </a:lnTo>
+              </a:path>
+              <a:path w="100000" h="100000">
+                <a:moveTo>
+                  <a:pt x="20000" y="74000"/>
+                </a:moveTo>
+                <a:lnTo>
+                  <a:pt x="80000" y="74000"/>
+                </a:lnTo>
+              </a:path>
+              <a:path w="100000" h="100000">
+                <a:moveTo>
+                  <a:pt x="30000" y="74000"/>
+                </a:moveTo>
+                <a:lnTo>
+                  <a:pt x="30000" y="50000"/>
+                </a:lnTo>
+              </a:path>
+              <a:path w="100000" h="100000">
+                <a:moveTo>
+                  <a:pt x="46000" y="74000"/>
+                </a:moveTo>
+                <a:lnTo>
+                  <a:pt x="46000" y="36000"/>
+                </a:lnTo>
+              </a:path>
+              <a:path w="100000" h="100000">
+                <a:moveTo>
+                  <a:pt x="62000" y="74000"/>
+                </a:moveTo>
+                <a:lnTo>
+                  <a:pt x="62000" y="56000"/>
+                </a:lnTo>
+              </a:path>
+              <a:path w="100000" h="100000">
+                <a:moveTo>
+                  <a:pt x="78000" y="74000"/>
+                </a:moveTo>
+                <a:lnTo>
+                  <a:pt x="78000" y="30000"/>
+                </a:lnTo>
+              </a:path>
+            </a:pathLst>
+          </a:custGeom>
+        </p:spPr>
+        <p:style>
+          <a:lnRef idx="1">
+            <a:schemeClr val="accent1"/>
+          </a:lnRef>
+          <a:fillRef idx="3">
+            <a:schemeClr val="accent1"/>
+          </a:fillRef>
+          <a:effectRef idx="2">
+            <a:schemeClr val="accent1"/>
+          </a:effectRef>
+          <a:fontRef idx="minor">
+            <a:schemeClr val="lt1"/>
+          </a:fontRef>
+        </p:style>
+        <p:txBody>
+          <a:bodyPr rtlCol="0" anchor="ctr"/>
+          <a:lstStyle/>
+          <a:p>
+            <a:pPr algn="ctr"/>
+          </a:p>
+        </p:txBody>
+      </p:sp>
+      <p:sp>
+        <p:nvSpPr>
+          <p:cNvPr id="3" name="TextBox 2"/>
           <p:cNvSpPr txBox="1"/>
           <p:nvPr/>
         </p:nvSpPr>
         <p:spPr>
           <a:xfrm>
-            <a:off x="548640" y="365760"/>
-            <a:ext cx="10515600" cy="640080"/>
+            <a:off x="1097280" y="365760"/>
+            <a:ext cx="10058400" cy="640080"/>
           </a:xfrm>
           <a:prstGeom prst="rect">
             <a:avLst/>
@@ -5699,7 +6902,7 @@
         </p:spPr>
         <p:txBody>
           <a:bodyPr wrap="square" anchor="t" lIns="45720" rIns="45720">
-            <a:normAutofit/>
+            <a:spAutoFit/>
           </a:bodyPr>
           <a:lstStyle/>
           <a:p>
@@ -5718,13 +6921,13 @@
       </p:sp>
       <p:sp>
         <p:nvSpPr>
-          <p:cNvPr id="3" name="Rectangle 2"/>
+          <p:cNvPr id="4" name="Rectangle 3"/>
           <p:cNvSpPr/>
           <p:nvPr/>
         </p:nvSpPr>
         <p:spPr>
           <a:xfrm>
-            <a:off x="548640" y="1024128"/>
+            <a:off x="1097280" y="1024128"/>
             <a:ext cx="2011680" cy="54864"/>
           </a:xfrm>
           <a:prstGeom prst="rect">
@@ -5762,7 +6965,7 @@
       </p:sp>
       <p:graphicFrame>
         <p:nvGraphicFramePr>
-          <p:cNvPr id="4" name="Chart 3"/>
+          <p:cNvPr id="5" name="Chart 4"/>
           <p:cNvGraphicFramePr>
             <a:graphicFrameLocks noGrp="1"/>
           </p:cNvGraphicFramePr>
@@ -5780,7 +6983,7 @@
       </p:graphicFrame>
       <p:sp>
         <p:nvSpPr>
-          <p:cNvPr id="5" name="TextBox 4"/>
+          <p:cNvPr id="6" name="TextBox 5"/>
           <p:cNvSpPr txBox="1"/>
           <p:nvPr/>
         </p:nvSpPr>
@@ -5796,7 +6999,7 @@
         </p:spPr>
         <p:txBody>
           <a:bodyPr wrap="square" anchor="t" lIns="45720" rIns="45720">
-            <a:normAutofit/>
+            <a:spAutoFit/>
           </a:bodyPr>
           <a:lstStyle/>
           <a:p>
@@ -5815,7 +7018,7 @@
       </p:sp>
       <p:sp>
         <p:nvSpPr>
-          <p:cNvPr id="6" name="TextBox 5"/>
+          <p:cNvPr id="7" name="TextBox 6"/>
           <p:cNvSpPr txBox="1"/>
           <p:nvPr/>
         </p:nvSpPr>
@@ -5831,7 +7034,7 @@
         </p:spPr>
         <p:txBody>
           <a:bodyPr wrap="square" anchor="t" lIns="45720" rIns="45720">
-            <a:normAutofit/>
+            <a:spAutoFit/>
           </a:bodyPr>
           <a:lstStyle/>
           <a:p>
@@ -5967,14 +7170,80 @@
       </p:sp>
       <p:sp>
         <p:nvSpPr>
-          <p:cNvPr id="4" name="TextBox 3"/>
+          <p:cNvPr id="4" name="Rectangle 3"/>
+          <p:cNvSpPr/>
+          <p:nvPr/>
+        </p:nvSpPr>
+        <p:spPr>
+          <a:xfrm>
+            <a:off x="548640" y="2999232"/>
+            <a:ext cx="822960" cy="822960"/>
+          </a:xfrm>
+          <a:noFill/>
+          <a:ln w="19050">
+            <a:solidFill>
+              <a:srgbClr val="D4A060"/>
+            </a:solidFill>
+          </a:ln>
+          <a:effectLst/>
+          <a:custGeom>
+            <a:pathLst>
+              <a:path w="100000" h="100000">
+                <a:moveTo>
+                  <a:pt x="30000" y="18000"/>
+                </a:moveTo>
+                <a:lnTo>
+                  <a:pt x="70000" y="18000"/>
+                </a:lnTo>
+                <a:lnTo>
+                  <a:pt x="70000" y="82000"/>
+                </a:lnTo>
+                <a:lnTo>
+                  <a:pt x="50000" y="66000"/>
+                </a:lnTo>
+                <a:lnTo>
+                  <a:pt x="30000" y="82000"/>
+                </a:lnTo>
+                <a:lnTo>
+                  <a:pt x="30000" y="18000"/>
+                </a:lnTo>
+                <a:close/>
+              </a:path>
+            </a:pathLst>
+          </a:custGeom>
+        </p:spPr>
+        <p:style>
+          <a:lnRef idx="1">
+            <a:schemeClr val="accent1"/>
+          </a:lnRef>
+          <a:fillRef idx="3">
+            <a:schemeClr val="accent1"/>
+          </a:fillRef>
+          <a:effectRef idx="2">
+            <a:schemeClr val="accent1"/>
+          </a:effectRef>
+          <a:fontRef idx="minor">
+            <a:schemeClr val="lt1"/>
+          </a:fontRef>
+        </p:style>
+        <p:txBody>
+          <a:bodyPr rtlCol="0" anchor="ctr"/>
+          <a:lstStyle/>
+          <a:p>
+            <a:pPr algn="ctr"/>
+          </a:p>
+        </p:txBody>
+      </p:sp>
+      <p:sp>
+        <p:nvSpPr>
+          <p:cNvPr id="5" name="TextBox 4"/>
           <p:cNvSpPr txBox="1"/>
           <p:nvPr/>
         </p:nvSpPr>
         <p:spPr>
           <a:xfrm>
-            <a:off x="822960" y="2971800"/>
-            <a:ext cx="10515600" cy="914400"/>
+            <a:off x="1554480" y="2971800"/>
+            <a:ext cx="10058400" cy="914400"/>
           </a:xfrm>
           <a:prstGeom prst="rect">
             <a:avLst/>
@@ -5983,7 +7252,7 @@
         </p:spPr>
         <p:txBody>
           <a:bodyPr wrap="square" anchor="ctr" lIns="45720" rIns="45720">
-            <a:normAutofit/>
+            <a:spAutoFit/>
           </a:bodyPr>
           <a:lstStyle/>
           <a:p>
@@ -6002,14 +7271,14 @@
       </p:sp>
       <p:sp>
         <p:nvSpPr>
-          <p:cNvPr id="5" name="TextBox 4"/>
+          <p:cNvPr id="6" name="TextBox 5"/>
           <p:cNvSpPr txBox="1"/>
           <p:nvPr/>
         </p:nvSpPr>
         <p:spPr>
           <a:xfrm>
-            <a:off x="822960" y="3886200"/>
-            <a:ext cx="10515600" cy="457200"/>
+            <a:off x="1554480" y="3886200"/>
+            <a:ext cx="10058400" cy="457200"/>
           </a:xfrm>
           <a:prstGeom prst="rect">
             <a:avLst/>
@@ -6018,7 +7287,7 @@
         </p:spPr>
         <p:txBody>
           <a:bodyPr wrap="square" anchor="t" lIns="45720" rIns="45720">
-            <a:normAutofit/>
+            <a:spAutoFit/>
           </a:bodyPr>
           <a:lstStyle/>
           <a:p>
@@ -6066,14 +7335,95 @@
       <p:grpSpPr/>
       <p:sp>
         <p:nvSpPr>
-          <p:cNvPr id="2" name="TextBox 1"/>
+          <p:cNvPr id="2" name="Rectangle 1"/>
+          <p:cNvSpPr/>
+          <p:nvPr/>
+        </p:nvSpPr>
+        <p:spPr>
+          <a:xfrm>
+            <a:off x="502920" y="384048"/>
+            <a:ext cx="457200" cy="457200"/>
+          </a:xfrm>
+          <a:noFill/>
+          <a:ln w="19050">
+            <a:solidFill>
+              <a:srgbClr val="D4A060"/>
+            </a:solidFill>
+          </a:ln>
+          <a:effectLst/>
+          <a:custGeom>
+            <a:pathLst>
+              <a:path w="100000" h="100000">
+                <a:moveTo>
+                  <a:pt x="24000" y="24000"/>
+                </a:moveTo>
+                <a:lnTo>
+                  <a:pt x="46000" y="24000"/>
+                </a:lnTo>
+                <a:lnTo>
+                  <a:pt x="46000" y="76000"/>
+                </a:lnTo>
+                <a:lnTo>
+                  <a:pt x="24000" y="76000"/>
+                </a:lnTo>
+                <a:lnTo>
+                  <a:pt x="24000" y="24000"/>
+                </a:lnTo>
+                <a:close/>
+              </a:path>
+              <a:path w="100000" h="100000">
+                <a:moveTo>
+                  <a:pt x="54000" y="24000"/>
+                </a:moveTo>
+                <a:lnTo>
+                  <a:pt x="76000" y="24000"/>
+                </a:lnTo>
+                <a:lnTo>
+                  <a:pt x="76000" y="76000"/>
+                </a:lnTo>
+                <a:lnTo>
+                  <a:pt x="54000" y="76000"/>
+                </a:lnTo>
+                <a:lnTo>
+                  <a:pt x="54000" y="24000"/>
+                </a:lnTo>
+                <a:close/>
+              </a:path>
+            </a:pathLst>
+          </a:custGeom>
+        </p:spPr>
+        <p:style>
+          <a:lnRef idx="1">
+            <a:schemeClr val="accent1"/>
+          </a:lnRef>
+          <a:fillRef idx="3">
+            <a:schemeClr val="accent1"/>
+          </a:fillRef>
+          <a:effectRef idx="2">
+            <a:schemeClr val="accent1"/>
+          </a:effectRef>
+          <a:fontRef idx="minor">
+            <a:schemeClr val="lt1"/>
+          </a:fontRef>
+        </p:style>
+        <p:txBody>
+          <a:bodyPr rtlCol="0" anchor="ctr"/>
+          <a:lstStyle/>
+          <a:p>
+            <a:pPr algn="ctr"/>
+          </a:p>
+        </p:txBody>
+      </p:sp>
+      <p:sp>
+        <p:nvSpPr>
+          <p:cNvPr id="3" name="TextBox 2"/>
           <p:cNvSpPr txBox="1"/>
           <p:nvPr/>
         </p:nvSpPr>
         <p:spPr>
           <a:xfrm>
-            <a:off x="548640" y="365760"/>
-            <a:ext cx="10515600" cy="640080"/>
+            <a:off x="1097280" y="365760"/>
+            <a:ext cx="10058400" cy="640080"/>
           </a:xfrm>
           <a:prstGeom prst="rect">
             <a:avLst/>
@@ -6082,7 +7432,7 @@
         </p:spPr>
         <p:txBody>
           <a:bodyPr wrap="square" anchor="t" lIns="45720" rIns="45720">
-            <a:normAutofit/>
+            <a:spAutoFit/>
           </a:bodyPr>
           <a:lstStyle/>
           <a:p>
@@ -6101,13 +7451,13 @@
       </p:sp>
       <p:sp>
         <p:nvSpPr>
-          <p:cNvPr id="3" name="Rectangle 2"/>
+          <p:cNvPr id="4" name="Rectangle 3"/>
           <p:cNvSpPr/>
           <p:nvPr/>
         </p:nvSpPr>
         <p:spPr>
           <a:xfrm>
-            <a:off x="548640" y="1024128"/>
+            <a:off x="1097280" y="1024128"/>
             <a:ext cx="2011680" cy="54864"/>
           </a:xfrm>
           <a:prstGeom prst="rect">
@@ -6145,7 +7495,7 @@
       </p:sp>
       <p:sp>
         <p:nvSpPr>
-          <p:cNvPr id="4" name="Rectangle 3"/>
+          <p:cNvPr id="5" name="Rectangle 4"/>
           <p:cNvSpPr/>
           <p:nvPr/>
         </p:nvSpPr>
@@ -6189,7 +7539,7 @@
       </p:sp>
       <p:sp>
         <p:nvSpPr>
-          <p:cNvPr id="5" name="Rectangle 4"/>
+          <p:cNvPr id="6" name="Rectangle 5"/>
           <p:cNvSpPr/>
           <p:nvPr/>
         </p:nvSpPr>
@@ -6233,7 +7583,7 @@
       </p:sp>
       <p:sp>
         <p:nvSpPr>
-          <p:cNvPr id="6" name="TextBox 5"/>
+          <p:cNvPr id="7" name="TextBox 6"/>
           <p:cNvSpPr txBox="1"/>
           <p:nvPr/>
         </p:nvSpPr>
@@ -6249,7 +7599,7 @@
         </p:spPr>
         <p:txBody>
           <a:bodyPr wrap="square" anchor="t" lIns="45720" rIns="45720">
-            <a:normAutofit/>
+            <a:spAutoFit/>
           </a:bodyPr>
           <a:lstStyle/>
           <a:p>
@@ -6268,7 +7618,7 @@
       </p:sp>
       <p:sp>
         <p:nvSpPr>
-          <p:cNvPr id="7" name="TextBox 6"/>
+          <p:cNvPr id="8" name="TextBox 7"/>
           <p:cNvSpPr txBox="1"/>
           <p:nvPr/>
         </p:nvSpPr>
@@ -6284,7 +7634,7 @@
         </p:spPr>
         <p:txBody>
           <a:bodyPr wrap="square" anchor="t" lIns="45720" rIns="45720">
-            <a:normAutofit/>
+            <a:spAutoFit/>
           </a:bodyPr>
           <a:lstStyle/>
           <a:p>
@@ -6303,7 +7653,7 @@
       </p:sp>
       <p:sp>
         <p:nvSpPr>
-          <p:cNvPr id="8" name="Rectangle 7"/>
+          <p:cNvPr id="9" name="Rectangle 8"/>
           <p:cNvSpPr/>
           <p:nvPr/>
         </p:nvSpPr>
@@ -6347,7 +7697,7 @@
       </p:sp>
       <p:sp>
         <p:nvSpPr>
-          <p:cNvPr id="9" name="TextBox 8"/>
+          <p:cNvPr id="10" name="TextBox 9"/>
           <p:cNvSpPr txBox="1"/>
           <p:nvPr/>
         </p:nvSpPr>
@@ -6363,7 +7713,7 @@
         </p:spPr>
         <p:txBody>
           <a:bodyPr wrap="square" anchor="t" lIns="45720" rIns="45720">
-            <a:normAutofit/>
+            <a:spAutoFit/>
           </a:bodyPr>
           <a:lstStyle/>
           <a:p>
@@ -6382,7 +7732,7 @@
       </p:sp>
       <p:sp>
         <p:nvSpPr>
-          <p:cNvPr id="10" name="Rectangle 9"/>
+          <p:cNvPr id="11" name="Rectangle 10"/>
           <p:cNvSpPr/>
           <p:nvPr/>
         </p:nvSpPr>
@@ -6426,7 +7776,7 @@
       </p:sp>
       <p:sp>
         <p:nvSpPr>
-          <p:cNvPr id="11" name="TextBox 10"/>
+          <p:cNvPr id="12" name="TextBox 11"/>
           <p:cNvSpPr txBox="1"/>
           <p:nvPr/>
         </p:nvSpPr>
@@ -6442,7 +7792,7 @@
         </p:spPr>
         <p:txBody>
           <a:bodyPr wrap="square" anchor="t" lIns="45720" rIns="45720">
-            <a:normAutofit/>
+            <a:spAutoFit/>
           </a:bodyPr>
           <a:lstStyle/>
           <a:p>
@@ -6461,7 +7811,7 @@
       </p:sp>
       <p:sp>
         <p:nvSpPr>
-          <p:cNvPr id="12" name="Rectangle 11"/>
+          <p:cNvPr id="13" name="Rectangle 12"/>
           <p:cNvSpPr/>
           <p:nvPr/>
         </p:nvSpPr>
@@ -6505,7 +7855,7 @@
       </p:sp>
       <p:sp>
         <p:nvSpPr>
-          <p:cNvPr id="13" name="TextBox 12"/>
+          <p:cNvPr id="14" name="TextBox 13"/>
           <p:cNvSpPr txBox="1"/>
           <p:nvPr/>
         </p:nvSpPr>
@@ -6521,7 +7871,7 @@
         </p:spPr>
         <p:txBody>
           <a:bodyPr wrap="square" anchor="t" lIns="45720" rIns="45720">
-            <a:normAutofit/>
+            <a:spAutoFit/>
           </a:bodyPr>
           <a:lstStyle/>
           <a:p>
@@ -6540,7 +7890,7 @@
       </p:sp>
       <p:sp>
         <p:nvSpPr>
-          <p:cNvPr id="14" name="Rectangle 13"/>
+          <p:cNvPr id="15" name="Rectangle 14"/>
           <p:cNvSpPr/>
           <p:nvPr/>
         </p:nvSpPr>
@@ -6584,7 +7934,7 @@
       </p:sp>
       <p:sp>
         <p:nvSpPr>
-          <p:cNvPr id="15" name="TextBox 14"/>
+          <p:cNvPr id="16" name="TextBox 15"/>
           <p:cNvSpPr txBox="1"/>
           <p:nvPr/>
         </p:nvSpPr>
@@ -6600,7 +7950,7 @@
         </p:spPr>
         <p:txBody>
           <a:bodyPr wrap="square" anchor="t" lIns="45720" rIns="45720">
-            <a:normAutofit/>
+            <a:spAutoFit/>
           </a:bodyPr>
           <a:lstStyle/>
           <a:p>
@@ -6619,7 +7969,7 @@
       </p:sp>
       <p:sp>
         <p:nvSpPr>
-          <p:cNvPr id="16" name="Rectangle 15"/>
+          <p:cNvPr id="17" name="Rectangle 16"/>
           <p:cNvSpPr/>
           <p:nvPr/>
         </p:nvSpPr>
@@ -6663,7 +8013,7 @@
       </p:sp>
       <p:sp>
         <p:nvSpPr>
-          <p:cNvPr id="17" name="TextBox 16"/>
+          <p:cNvPr id="18" name="TextBox 17"/>
           <p:cNvSpPr txBox="1"/>
           <p:nvPr/>
         </p:nvSpPr>
@@ -6679,7 +8029,7 @@
         </p:spPr>
         <p:txBody>
           <a:bodyPr wrap="square" anchor="t" lIns="45720" rIns="45720">
-            <a:normAutofit/>
+            <a:spAutoFit/>
           </a:bodyPr>
           <a:lstStyle/>
           <a:p>
@@ -6698,7 +8048,7 @@
       </p:sp>
       <p:sp>
         <p:nvSpPr>
-          <p:cNvPr id="18" name="Rectangle 17"/>
+          <p:cNvPr id="19" name="Rectangle 18"/>
           <p:cNvSpPr/>
           <p:nvPr/>
         </p:nvSpPr>
@@ -6742,7 +8092,7 @@
       </p:sp>
       <p:sp>
         <p:nvSpPr>
-          <p:cNvPr id="19" name="TextBox 18"/>
+          <p:cNvPr id="20" name="TextBox 19"/>
           <p:cNvSpPr txBox="1"/>
           <p:nvPr/>
         </p:nvSpPr>
@@ -6758,7 +8108,7 @@
         </p:spPr>
         <p:txBody>
           <a:bodyPr wrap="square" anchor="t" lIns="45720" rIns="45720">
-            <a:normAutofit/>
+            <a:spAutoFit/>
           </a:bodyPr>
           <a:lstStyle/>
           <a:p>
@@ -6777,7 +8127,7 @@
       </p:sp>
       <p:sp>
         <p:nvSpPr>
-          <p:cNvPr id="20" name="Rectangle 19"/>
+          <p:cNvPr id="21" name="Rectangle 20"/>
           <p:cNvSpPr/>
           <p:nvPr/>
         </p:nvSpPr>
@@ -6821,7 +8171,7 @@
       </p:sp>
       <p:sp>
         <p:nvSpPr>
-          <p:cNvPr id="21" name="TextBox 20"/>
+          <p:cNvPr id="22" name="TextBox 21"/>
           <p:cNvSpPr txBox="1"/>
           <p:nvPr/>
         </p:nvSpPr>
@@ -6837,7 +8187,7 @@
         </p:spPr>
         <p:txBody>
           <a:bodyPr wrap="square" anchor="t" lIns="45720" rIns="45720">
-            <a:normAutofit/>
+            <a:spAutoFit/>
           </a:bodyPr>
           <a:lstStyle/>
           <a:p>
@@ -6856,7 +8206,7 @@
       </p:sp>
       <p:sp>
         <p:nvSpPr>
-          <p:cNvPr id="22" name="Rectangle 21"/>
+          <p:cNvPr id="23" name="Rectangle 22"/>
           <p:cNvSpPr/>
           <p:nvPr/>
         </p:nvSpPr>
@@ -6900,7 +8250,7 @@
       </p:sp>
       <p:sp>
         <p:nvSpPr>
-          <p:cNvPr id="23" name="TextBox 22"/>
+          <p:cNvPr id="24" name="TextBox 23"/>
           <p:cNvSpPr txBox="1"/>
           <p:nvPr/>
         </p:nvSpPr>
@@ -6916,7 +8266,7 @@
         </p:spPr>
         <p:txBody>
           <a:bodyPr wrap="square" anchor="t" lIns="45720" rIns="45720">
-            <a:normAutofit/>
+            <a:spAutoFit/>
           </a:bodyPr>
           <a:lstStyle/>
           <a:p>
@@ -6935,7 +8285,7 @@
       </p:sp>
       <p:sp>
         <p:nvSpPr>
-          <p:cNvPr id="24" name="TextBox 23"/>
+          <p:cNvPr id="25" name="TextBox 24"/>
           <p:cNvSpPr txBox="1"/>
           <p:nvPr/>
         </p:nvSpPr>
@@ -6951,7 +8301,7 @@
         </p:spPr>
         <p:txBody>
           <a:bodyPr wrap="square" anchor="t" lIns="45720" rIns="45720">
-            <a:normAutofit/>
+            <a:spAutoFit/>
           </a:bodyPr>
           <a:lstStyle/>
           <a:p>
@@ -6970,7 +8320,7 @@
       </p:sp>
       <p:sp>
         <p:nvSpPr>
-          <p:cNvPr id="25" name="TextBox 24"/>
+          <p:cNvPr id="26" name="TextBox 25"/>
           <p:cNvSpPr txBox="1"/>
           <p:nvPr/>
         </p:nvSpPr>
@@ -6986,7 +8336,7 @@
         </p:spPr>
         <p:txBody>
           <a:bodyPr wrap="square" anchor="t" lIns="45720" rIns="45720">
-            <a:normAutofit/>
+            <a:spAutoFit/>
           </a:bodyPr>
           <a:lstStyle/>
           <a:p>
@@ -7034,14 +8384,153 @@
       <p:grpSpPr/>
       <p:sp>
         <p:nvSpPr>
-          <p:cNvPr id="2" name="TextBox 1"/>
+          <p:cNvPr id="2" name="Rectangle 1"/>
+          <p:cNvSpPr/>
+          <p:nvPr/>
+        </p:nvSpPr>
+        <p:spPr>
+          <a:xfrm>
+            <a:off x="502920" y="384048"/>
+            <a:ext cx="457200" cy="457200"/>
+          </a:xfrm>
+          <a:noFill/>
+          <a:ln w="19050">
+            <a:solidFill>
+              <a:srgbClr val="D4A060"/>
+            </a:solidFill>
+          </a:ln>
+          <a:effectLst/>
+          <a:custGeom>
+            <a:pathLst>
+              <a:path w="100000" h="100000">
+                <a:moveTo>
+                  <a:pt x="84000" y="50000"/>
+                </a:moveTo>
+                <a:lnTo>
+                  <a:pt x="82841" y="58799"/>
+                </a:lnTo>
+                <a:lnTo>
+                  <a:pt x="79444" y="67000"/>
+                </a:lnTo>
+                <a:lnTo>
+                  <a:pt x="74041" y="74041"/>
+                </a:lnTo>
+                <a:lnTo>
+                  <a:pt x="67000" y="79444"/>
+                </a:lnTo>
+                <a:lnTo>
+                  <a:pt x="58799" y="82841"/>
+                </a:lnTo>
+                <a:lnTo>
+                  <a:pt x="50000" y="84000"/>
+                </a:lnTo>
+                <a:lnTo>
+                  <a:pt x="41200" y="82841"/>
+                </a:lnTo>
+                <a:lnTo>
+                  <a:pt x="33000" y="79444"/>
+                </a:lnTo>
+                <a:lnTo>
+                  <a:pt x="25958" y="74041"/>
+                </a:lnTo>
+                <a:lnTo>
+                  <a:pt x="20555" y="67000"/>
+                </a:lnTo>
+                <a:lnTo>
+                  <a:pt x="17158" y="58799"/>
+                </a:lnTo>
+                <a:lnTo>
+                  <a:pt x="16000" y="50000"/>
+                </a:lnTo>
+                <a:lnTo>
+                  <a:pt x="17158" y="41200"/>
+                </a:lnTo>
+                <a:lnTo>
+                  <a:pt x="20555" y="33000"/>
+                </a:lnTo>
+                <a:lnTo>
+                  <a:pt x="25958" y="25958"/>
+                </a:lnTo>
+                <a:lnTo>
+                  <a:pt x="32999" y="20555"/>
+                </a:lnTo>
+                <a:lnTo>
+                  <a:pt x="41200" y="17158"/>
+                </a:lnTo>
+                <a:lnTo>
+                  <a:pt x="49999" y="16000"/>
+                </a:lnTo>
+                <a:lnTo>
+                  <a:pt x="58799" y="17158"/>
+                </a:lnTo>
+                <a:lnTo>
+                  <a:pt x="67000" y="20555"/>
+                </a:lnTo>
+                <a:lnTo>
+                  <a:pt x="74041" y="25958"/>
+                </a:lnTo>
+                <a:lnTo>
+                  <a:pt x="79444" y="32999"/>
+                </a:lnTo>
+                <a:lnTo>
+                  <a:pt x="82841" y="41200"/>
+                </a:lnTo>
+                <a:lnTo>
+                  <a:pt x="84000" y="50000"/>
+                </a:lnTo>
+                <a:close/>
+              </a:path>
+              <a:path w="100000" h="100000">
+                <a:moveTo>
+                  <a:pt x="50000" y="50000"/>
+                </a:moveTo>
+                <a:lnTo>
+                  <a:pt x="50000" y="26000"/>
+                </a:lnTo>
+              </a:path>
+              <a:path w="100000" h="100000">
+                <a:moveTo>
+                  <a:pt x="50000" y="50000"/>
+                </a:moveTo>
+                <a:lnTo>
+                  <a:pt x="70000" y="50000"/>
+                </a:lnTo>
+              </a:path>
+            </a:pathLst>
+          </a:custGeom>
+        </p:spPr>
+        <p:style>
+          <a:lnRef idx="1">
+            <a:schemeClr val="accent1"/>
+          </a:lnRef>
+          <a:fillRef idx="3">
+            <a:schemeClr val="accent1"/>
+          </a:fillRef>
+          <a:effectRef idx="2">
+            <a:schemeClr val="accent1"/>
+          </a:effectRef>
+          <a:fontRef idx="minor">
+            <a:schemeClr val="lt1"/>
+          </a:fontRef>
+        </p:style>
+        <p:txBody>
+          <a:bodyPr rtlCol="0" anchor="ctr"/>
+          <a:lstStyle/>
+          <a:p>
+            <a:pPr algn="ctr"/>
+          </a:p>
+        </p:txBody>
+      </p:sp>
+      <p:sp>
+        <p:nvSpPr>
+          <p:cNvPr id="3" name="TextBox 2"/>
           <p:cNvSpPr txBox="1"/>
           <p:nvPr/>
         </p:nvSpPr>
         <p:spPr>
           <a:xfrm>
-            <a:off x="548640" y="365760"/>
-            <a:ext cx="10515600" cy="640080"/>
+            <a:off x="1097280" y="365760"/>
+            <a:ext cx="10058400" cy="640080"/>
           </a:xfrm>
           <a:prstGeom prst="rect">
             <a:avLst/>
@@ -7050,7 +8539,7 @@
         </p:spPr>
         <p:txBody>
           <a:bodyPr wrap="square" anchor="t" lIns="45720" rIns="45720">
-            <a:normAutofit/>
+            <a:spAutoFit/>
           </a:bodyPr>
           <a:lstStyle/>
           <a:p>
@@ -7069,13 +8558,13 @@
       </p:sp>
       <p:sp>
         <p:nvSpPr>
-          <p:cNvPr id="3" name="Rectangle 2"/>
+          <p:cNvPr id="4" name="Rectangle 3"/>
           <p:cNvSpPr/>
           <p:nvPr/>
         </p:nvSpPr>
         <p:spPr>
           <a:xfrm>
-            <a:off x="548640" y="1024128"/>
+            <a:off x="1097280" y="1024128"/>
             <a:ext cx="2011680" cy="54864"/>
           </a:xfrm>
           <a:prstGeom prst="rect">
@@ -7113,7 +8602,7 @@
       </p:sp>
       <p:sp>
         <p:nvSpPr>
-          <p:cNvPr id="4" name="Rectangle 3"/>
+          <p:cNvPr id="5" name="Rectangle 4"/>
           <p:cNvSpPr/>
           <p:nvPr/>
         </p:nvSpPr>
@@ -7157,7 +8646,7 @@
       </p:sp>
       <p:sp>
         <p:nvSpPr>
-          <p:cNvPr id="5" name="Rectangle 4"/>
+          <p:cNvPr id="6" name="Rectangle 5"/>
           <p:cNvSpPr/>
           <p:nvPr/>
         </p:nvSpPr>
@@ -7201,7 +8690,7 @@
       </p:sp>
       <p:sp>
         <p:nvSpPr>
-          <p:cNvPr id="6" name="TextBox 5"/>
+          <p:cNvPr id="7" name="TextBox 6"/>
           <p:cNvSpPr txBox="1"/>
           <p:nvPr/>
         </p:nvSpPr>
@@ -7217,7 +8706,7 @@
         </p:spPr>
         <p:txBody>
           <a:bodyPr wrap="square" anchor="t" lIns="45720" rIns="45720">
-            <a:normAutofit/>
+            <a:spAutoFit/>
           </a:bodyPr>
           <a:lstStyle/>
           <a:p>
@@ -7236,7 +8725,7 @@
       </p:sp>
       <p:sp>
         <p:nvSpPr>
-          <p:cNvPr id="7" name="TextBox 6"/>
+          <p:cNvPr id="8" name="TextBox 7"/>
           <p:cNvSpPr txBox="1"/>
           <p:nvPr/>
         </p:nvSpPr>
@@ -7252,7 +8741,7 @@
         </p:spPr>
         <p:txBody>
           <a:bodyPr wrap="square" anchor="t" lIns="45720" rIns="45720">
-            <a:normAutofit/>
+            <a:spAutoFit/>
           </a:bodyPr>
           <a:lstStyle/>
           <a:p>
@@ -7271,7 +8760,7 @@
       </p:sp>
       <p:sp>
         <p:nvSpPr>
-          <p:cNvPr id="8" name="Rectangle 7"/>
+          <p:cNvPr id="9" name="Rectangle 8"/>
           <p:cNvSpPr/>
           <p:nvPr/>
         </p:nvSpPr>
@@ -7315,7 +8804,7 @@
       </p:sp>
       <p:sp>
         <p:nvSpPr>
-          <p:cNvPr id="9" name="TextBox 8"/>
+          <p:cNvPr id="10" name="TextBox 9"/>
           <p:cNvSpPr txBox="1"/>
           <p:nvPr/>
         </p:nvSpPr>
@@ -7331,7 +8820,7 @@
         </p:spPr>
         <p:txBody>
           <a:bodyPr wrap="square" anchor="t" lIns="45720" rIns="45720">
-            <a:normAutofit/>
+            <a:spAutoFit/>
           </a:bodyPr>
           <a:lstStyle/>
           <a:p>
@@ -7350,7 +8839,7 @@
       </p:sp>
       <p:sp>
         <p:nvSpPr>
-          <p:cNvPr id="10" name="TextBox 9"/>
+          <p:cNvPr id="11" name="TextBox 10"/>
           <p:cNvSpPr txBox="1"/>
           <p:nvPr/>
         </p:nvSpPr>
@@ -7366,7 +8855,7 @@
         </p:spPr>
         <p:txBody>
           <a:bodyPr wrap="square" anchor="t" lIns="45720" rIns="45720">
-            <a:normAutofit/>
+            <a:spAutoFit/>
           </a:bodyPr>
           <a:lstStyle/>
           <a:p>
@@ -7385,7 +8874,7 @@
       </p:sp>
       <p:sp>
         <p:nvSpPr>
-          <p:cNvPr id="11" name="Rectangle 10"/>
+          <p:cNvPr id="12" name="Rectangle 11"/>
           <p:cNvSpPr/>
           <p:nvPr/>
         </p:nvSpPr>
@@ -7429,7 +8918,7 @@
       </p:sp>
       <p:sp>
         <p:nvSpPr>
-          <p:cNvPr id="12" name="TextBox 11"/>
+          <p:cNvPr id="13" name="TextBox 12"/>
           <p:cNvSpPr txBox="1"/>
           <p:nvPr/>
         </p:nvSpPr>
@@ -7445,7 +8934,7 @@
         </p:spPr>
         <p:txBody>
           <a:bodyPr wrap="square" anchor="t" lIns="45720" rIns="45720">
-            <a:normAutofit/>
+            <a:spAutoFit/>
           </a:bodyPr>
           <a:lstStyle/>
           <a:p>
@@ -7464,7 +8953,7 @@
       </p:sp>
       <p:sp>
         <p:nvSpPr>
-          <p:cNvPr id="13" name="TextBox 12"/>
+          <p:cNvPr id="14" name="TextBox 13"/>
           <p:cNvSpPr txBox="1"/>
           <p:nvPr/>
         </p:nvSpPr>
@@ -7480,7 +8969,7 @@
         </p:spPr>
         <p:txBody>
           <a:bodyPr wrap="square" anchor="t" lIns="45720" rIns="45720">
-            <a:normAutofit/>
+            <a:spAutoFit/>
           </a:bodyPr>
           <a:lstStyle/>
           <a:p>
@@ -7499,7 +8988,7 @@
       </p:sp>
       <p:sp>
         <p:nvSpPr>
-          <p:cNvPr id="14" name="Rectangle 13"/>
+          <p:cNvPr id="15" name="Rectangle 14"/>
           <p:cNvSpPr/>
           <p:nvPr/>
         </p:nvSpPr>
@@ -7543,7 +9032,7 @@
       </p:sp>
       <p:sp>
         <p:nvSpPr>
-          <p:cNvPr id="15" name="TextBox 14"/>
+          <p:cNvPr id="16" name="TextBox 15"/>
           <p:cNvSpPr txBox="1"/>
           <p:nvPr/>
         </p:nvSpPr>
@@ -7559,7 +9048,7 @@
         </p:spPr>
         <p:txBody>
           <a:bodyPr wrap="square" anchor="t" lIns="45720" rIns="45720">
-            <a:normAutofit/>
+            <a:spAutoFit/>
           </a:bodyPr>
           <a:lstStyle/>
           <a:p>
@@ -7578,7 +9067,7 @@
       </p:sp>
       <p:sp>
         <p:nvSpPr>
-          <p:cNvPr id="16" name="TextBox 15"/>
+          <p:cNvPr id="17" name="TextBox 16"/>
           <p:cNvSpPr txBox="1"/>
           <p:nvPr/>
         </p:nvSpPr>
@@ -7594,7 +9083,7 @@
         </p:spPr>
         <p:txBody>
           <a:bodyPr wrap="square" anchor="t" lIns="45720" rIns="45720">
-            <a:normAutofit/>
+            <a:spAutoFit/>
           </a:bodyPr>
           <a:lstStyle/>
           <a:p>
@@ -7613,7 +9102,7 @@
       </p:sp>
       <p:sp>
         <p:nvSpPr>
-          <p:cNvPr id="17" name="TextBox 16"/>
+          <p:cNvPr id="18" name="TextBox 17"/>
           <p:cNvSpPr txBox="1"/>
           <p:nvPr/>
         </p:nvSpPr>
@@ -7629,7 +9118,7 @@
         </p:spPr>
         <p:txBody>
           <a:bodyPr wrap="square" anchor="t" lIns="45720" rIns="45720">
-            <a:normAutofit/>
+            <a:spAutoFit/>
           </a:bodyPr>
           <a:lstStyle/>
           <a:p>
@@ -7648,7 +9137,7 @@
       </p:sp>
       <p:sp>
         <p:nvSpPr>
-          <p:cNvPr id="18" name="TextBox 17"/>
+          <p:cNvPr id="19" name="TextBox 18"/>
           <p:cNvSpPr txBox="1"/>
           <p:nvPr/>
         </p:nvSpPr>
@@ -7664,7 +9153,7 @@
         </p:spPr>
         <p:txBody>
           <a:bodyPr wrap="square" anchor="t" lIns="45720" rIns="45720">
-            <a:normAutofit/>
+            <a:spAutoFit/>
           </a:bodyPr>
           <a:lstStyle/>
           <a:p>
@@ -7712,14 +9201,101 @@
       <p:grpSpPr/>
       <p:sp>
         <p:nvSpPr>
-          <p:cNvPr id="2" name="TextBox 1"/>
+          <p:cNvPr id="2" name="Rectangle 1"/>
+          <p:cNvSpPr/>
+          <p:nvPr/>
+        </p:nvSpPr>
+        <p:spPr>
+          <a:xfrm>
+            <a:off x="502920" y="384048"/>
+            <a:ext cx="457200" cy="457200"/>
+          </a:xfrm>
+          <a:noFill/>
+          <a:ln w="19050">
+            <a:solidFill>
+              <a:srgbClr val="D4A060"/>
+            </a:solidFill>
+          </a:ln>
+          <a:effectLst/>
+          <a:custGeom>
+            <a:pathLst>
+              <a:path w="100000" h="100000">
+                <a:moveTo>
+                  <a:pt x="20000" y="28000"/>
+                </a:moveTo>
+                <a:lnTo>
+                  <a:pt x="80000" y="28000"/>
+                </a:lnTo>
+                <a:lnTo>
+                  <a:pt x="80000" y="72000"/>
+                </a:lnTo>
+                <a:lnTo>
+                  <a:pt x="20000" y="72000"/>
+                </a:lnTo>
+                <a:lnTo>
+                  <a:pt x="20000" y="28000"/>
+                </a:lnTo>
+                <a:close/>
+              </a:path>
+              <a:path w="100000" h="100000">
+                <a:moveTo>
+                  <a:pt x="20000" y="48000"/>
+                </a:moveTo>
+                <a:lnTo>
+                  <a:pt x="80000" y="48000"/>
+                </a:lnTo>
+              </a:path>
+              <a:path w="100000" h="100000">
+                <a:moveTo>
+                  <a:pt x="44000" y="28000"/>
+                </a:moveTo>
+                <a:lnTo>
+                  <a:pt x="44000" y="72000"/>
+                </a:lnTo>
+              </a:path>
+              <a:path w="100000" h="100000">
+                <a:moveTo>
+                  <a:pt x="62000" y="28000"/>
+                </a:moveTo>
+                <a:lnTo>
+                  <a:pt x="62000" y="72000"/>
+                </a:lnTo>
+              </a:path>
+            </a:pathLst>
+          </a:custGeom>
+        </p:spPr>
+        <p:style>
+          <a:lnRef idx="1">
+            <a:schemeClr val="accent1"/>
+          </a:lnRef>
+          <a:fillRef idx="3">
+            <a:schemeClr val="accent1"/>
+          </a:fillRef>
+          <a:effectRef idx="2">
+            <a:schemeClr val="accent1"/>
+          </a:effectRef>
+          <a:fontRef idx="minor">
+            <a:schemeClr val="lt1"/>
+          </a:fontRef>
+        </p:style>
+        <p:txBody>
+          <a:bodyPr rtlCol="0" anchor="ctr"/>
+          <a:lstStyle/>
+          <a:p>
+            <a:pPr algn="ctr"/>
+          </a:p>
+        </p:txBody>
+      </p:sp>
+      <p:sp>
+        <p:nvSpPr>
+          <p:cNvPr id="3" name="TextBox 2"/>
           <p:cNvSpPr txBox="1"/>
           <p:nvPr/>
         </p:nvSpPr>
         <p:spPr>
           <a:xfrm>
-            <a:off x="548640" y="365760"/>
-            <a:ext cx="10515600" cy="640080"/>
+            <a:off x="1097280" y="365760"/>
+            <a:ext cx="10058400" cy="640080"/>
           </a:xfrm>
           <a:prstGeom prst="rect">
             <a:avLst/>
@@ -7728,7 +9304,7 @@
         </p:spPr>
         <p:txBody>
           <a:bodyPr wrap="square" anchor="t" lIns="45720" rIns="45720">
-            <a:normAutofit/>
+            <a:spAutoFit/>
           </a:bodyPr>
           <a:lstStyle/>
           <a:p>
@@ -7747,13 +9323,13 @@
       </p:sp>
       <p:sp>
         <p:nvSpPr>
-          <p:cNvPr id="3" name="Rectangle 2"/>
+          <p:cNvPr id="4" name="Rectangle 3"/>
           <p:cNvSpPr/>
           <p:nvPr/>
         </p:nvSpPr>
         <p:spPr>
           <a:xfrm>
-            <a:off x="548640" y="1024128"/>
+            <a:off x="1097280" y="1024128"/>
             <a:ext cx="2011680" cy="54864"/>
           </a:xfrm>
           <a:prstGeom prst="rect">
@@ -7791,7 +9367,7 @@
       </p:sp>
       <p:graphicFrame>
         <p:nvGraphicFramePr>
-          <p:cNvPr id="4" name="Table 3"/>
+          <p:cNvPr id="5" name="Table 4"/>
           <p:cNvGraphicFramePr>
             <a:graphicFrameLocks noGrp="1"/>
           </p:cNvGraphicFramePr>
@@ -8227,7 +9803,7 @@
       </p:graphicFrame>
       <p:sp>
         <p:nvSpPr>
-          <p:cNvPr id="5" name="TextBox 4"/>
+          <p:cNvPr id="6" name="TextBox 5"/>
           <p:cNvSpPr txBox="1"/>
           <p:nvPr/>
         </p:nvSpPr>
@@ -8243,7 +9819,7 @@
         </p:spPr>
         <p:txBody>
           <a:bodyPr wrap="square" anchor="t" lIns="45720" rIns="45720">
-            <a:normAutofit/>
+            <a:spAutoFit/>
           </a:bodyPr>
           <a:lstStyle/>
           <a:p>
@@ -8262,7 +9838,7 @@
       </p:sp>
       <p:sp>
         <p:nvSpPr>
-          <p:cNvPr id="6" name="TextBox 5"/>
+          <p:cNvPr id="7" name="TextBox 6"/>
           <p:cNvSpPr txBox="1"/>
           <p:nvPr/>
         </p:nvSpPr>
@@ -8278,7 +9854,7 @@
         </p:spPr>
         <p:txBody>
           <a:bodyPr wrap="square" anchor="t" lIns="45720" rIns="45720">
-            <a:normAutofit/>
+            <a:spAutoFit/>
           </a:bodyPr>
           <a:lstStyle/>
           <a:p>
@@ -8311,45 +9887,39 @@
   <a:themeElements>
     <a:clrScheme name="Office">
       <a:dk1>
-        <a:sysClr val="windowText" lastClr="000000"/>
+        <a:srgbClr val="0D1117"/>
       </a:dk1>
       <a:lt1>
-        <a:sysClr val="window" lastClr="FFFFFF"/>
+        <a:srgbClr val="FFFFFF"/>
       </a:lt1>
       <a:dk2>
-        <a:srgbClr val="1F497D"/>
+        <a:srgbClr val="58A6FF"/>
       </a:dk2>
       <a:lt2>
-        <a:srgbClr val="EEECE1"/>
+        <a:srgbClr val="151D2E"/>
       </a:lt2>
       <a:accent1>
-        <a:srgbClr val="4F81BD"/>
+        <a:srgbClr val="D4A060"/>
       </a:accent1>
       <a:accent2>
-        <a:srgbClr val="C0504D"/>
+        <a:srgbClr val="58A6FF"/>
       </a:accent2>
       <a:accent3>
-        <a:srgbClr val="9BBB59"/>
+        <a:srgbClr val="3FB950"/>
       </a:accent3>
       <a:accent4>
-        <a:srgbClr val="8064A2"/>
+        <a:srgbClr val="8B949E"/>
       </a:accent4>
       <a:accent5>
-        <a:srgbClr val="4BACC6"/>
+        <a:srgbClr val="30363D"/>
       </a:accent5>
       <a:accent6>
-        <a:srgbClr val="F79646"/>
+        <a:srgbClr val="D4A060"/>
       </a:accent6>
-      <a:hlink>
-        <a:srgbClr val="0000FF"/>
-      </a:hlink>
-      <a:folHlink>
-        <a:srgbClr val="800080"/>
-      </a:folHlink>
     </a:clrScheme>
     <a:fontScheme name="Office">
       <a:majorFont>
-        <a:latin typeface="Calibri"/>
+        <a:latin typeface="Microsoft YaHei"/>
         <a:ea typeface=""/>
         <a:cs typeface=""/>
         <a:font script="Jpan" typeface="ＭＳ Ｐゴシック"/>
@@ -8384,7 +9954,7 @@
         <a:font script="Geor" typeface="Sylfaen"/>
       </a:majorFont>
       <a:minorFont>
-        <a:latin typeface="Calibri"/>
+        <a:latin typeface="Microsoft YaHei"/>
         <a:ea typeface=""/>
         <a:cs typeface=""/>
         <a:font script="Jpan" typeface="ＭＳ Ｐゴシック"/>

</xml_diff>

<commit_message>
P1 polish: chart refinement + section visualization + QA 2.0
- Chart (both engines): gridlines, data labels, bottom legend, distinct per-series colors, single-point emphasis (accent), multi-series clustered column/line; python-pptx plot area made transparent (OOXML noFill patch) so dark theme shows through
- Section pages (both engines): big index number + vertical divider + geometric ring decoration for narrative rhythm; number parsed from leading 'NN ' in title
- QA 2.0 (scripts/qa2.py): programmatic layout audit — bounds, placeholders, font floor >=11pt, transitions, vector icons, brand theme, 0-100 score
- sample-brief chart upgraded to 2-series column with emphasis[3] to showcase
- Both decks: QA 2.0 score 100/100, 0 bounds, 12 transitions, 0 placeholders
</commit_message>
<xml_diff>
--- a/output/deck.pptx
+++ b/output/deck.pptx
@@ -141,6 +141,19 @@
               </c:strCache>
             </c:strRef>
           </c:tx>
+          <c:spPr>
+            <a:solidFill>
+              <a:srgbClr val="D4A060"/>
+            </a:solidFill>
+          </c:spPr>
+          <c:dPt>
+            <c:idx val="3"/>
+            <c:spPr>
+              <a:solidFill>
+                <a:srgbClr val="3FB950"/>
+              </a:solidFill>
+            </c:spPr>
+          </c:dPt>
           <c:cat>
             <c:strRef>
               <c:f>Sheet1!$A$2:$A$5</c:f>
@@ -183,6 +196,100 @@
             </c:numRef>
           </c:val>
         </c:ser>
+        <c:ser>
+          <c:idx val="1"/>
+          <c:order val="1"/>
+          <c:tx>
+            <c:strRef>
+              <c:f>Sheet1!$C$1</c:f>
+              <c:strCache>
+                <c:ptCount val="1"/>
+                <c:pt idx="0">
+                  <c:v>通用 Agent 市场</c:v>
+                </c:pt>
+              </c:strCache>
+            </c:strRef>
+          </c:tx>
+          <c:spPr>
+            <a:solidFill>
+              <a:srgbClr val="58A6FF"/>
+            </a:solidFill>
+          </c:spPr>
+          <c:dPt>
+            <c:idx val="3"/>
+            <c:spPr>
+              <a:solidFill>
+                <a:srgbClr val="3FB950"/>
+              </a:solidFill>
+            </c:spPr>
+          </c:dPt>
+          <c:cat>
+            <c:strRef>
+              <c:f>Sheet1!$A$2:$A$5</c:f>
+              <c:strCache>
+                <c:ptCount val="4"/>
+                <c:pt idx="0">
+                  <c:v>2024</c:v>
+                </c:pt>
+                <c:pt idx="1">
+                  <c:v>2025</c:v>
+                </c:pt>
+                <c:pt idx="2">
+                  <c:v>2026E</c:v>
+                </c:pt>
+                <c:pt idx="3">
+                  <c:v>2027E</c:v>
+                </c:pt>
+              </c:strCache>
+            </c:strRef>
+          </c:cat>
+          <c:val>
+            <c:numRef>
+              <c:f>Sheet1!$C$2:$C$5</c:f>
+              <c:numCache>
+                <c:formatCode>General</c:formatCode>
+                <c:ptCount val="4"/>
+                <c:pt idx="0">
+                  <c:v>200</c:v>
+                </c:pt>
+                <c:pt idx="1">
+                  <c:v>420</c:v>
+                </c:pt>
+                <c:pt idx="2">
+                  <c:v>760</c:v>
+                </c:pt>
+                <c:pt idx="3">
+                  <c:v>1280</c:v>
+                </c:pt>
+              </c:numCache>
+            </c:numRef>
+          </c:val>
+        </c:ser>
+        <c:dLbls>
+          <c:numFmt formatCode="0" sourceLinked="0"/>
+          <c:txPr>
+            <a:bodyPr/>
+            <a:lstStyle/>
+            <a:p>
+              <a:pPr>
+                <a:defRPr sz="1000">
+                  <a:solidFill>
+                    <a:srgbClr val="FFFFFF"/>
+                  </a:solidFill>
+                  <a:latin typeface="Microsoft YaHei"/>
+                </a:defRPr>
+              </a:pPr>
+            </a:p>
+          </c:txPr>
+          <c:dLblPos val="outEnd"/>
+          <c:showLegendKey val="0"/>
+          <c:showVal val="1"/>
+          <c:showCatName val="0"/>
+          <c:showSerName val="0"/>
+          <c:showPercent val="0"/>
+          <c:showBubbleSize val="0"/>
+          <c:showLeaderLines val="1"/>
+        </c:dLbls>
         <c:axId val="-2068027336"/>
         <c:axId val="-2113994440"/>
       </c:barChart>
@@ -196,6 +303,19 @@
         <c:majorTickMark val="out"/>
         <c:minorTickMark val="none"/>
         <c:tickLblPos val="nextTo"/>
+        <c:txPr>
+          <a:bodyPr/>
+          <a:lstStyle/>
+          <a:p>
+            <a:pPr>
+              <a:defRPr sz="1100">
+                <a:solidFill>
+                  <a:srgbClr val="FFFFFF"/>
+                </a:solidFill>
+              </a:defRPr>
+            </a:pPr>
+          </a:p>
+        </c:txPr>
         <c:crossAx val="-2113994440"/>
         <c:crosses val="autoZero"/>
         <c:auto val="1"/>
@@ -208,14 +328,53 @@
         <c:scaling/>
         <c:delete val="0"/>
         <c:axPos val="l"/>
-        <c:majorGridlines/>
+        <c:majorGridlines>
+          <c:spPr>
+            <a:ln w="6350">
+              <a:solidFill>
+                <a:srgbClr val="30363D"/>
+              </a:solidFill>
+            </a:ln>
+          </c:spPr>
+        </c:majorGridlines>
         <c:majorTickMark val="out"/>
         <c:minorTickMark val="none"/>
         <c:tickLblPos val="nextTo"/>
+        <c:txPr>
+          <a:bodyPr/>
+          <a:lstStyle/>
+          <a:p>
+            <a:pPr>
+              <a:defRPr sz="1000">
+                <a:solidFill>
+                  <a:srgbClr val="8B949E"/>
+                </a:solidFill>
+              </a:defRPr>
+            </a:pPr>
+          </a:p>
+        </c:txPr>
         <c:crossAx val="-2068027336"/>
         <c:crosses val="autoZero"/>
       </c:valAx>
     </c:plotArea>
+    <c:legend>
+      <c:legendPos val="b"/>
+      <c:overlay val="0"/>
+      <c:txPr>
+        <a:bodyPr/>
+        <a:lstStyle/>
+        <a:p>
+          <a:pPr>
+            <a:defRPr sz="1000">
+              <a:solidFill>
+                <a:srgbClr val="FFFFFF"/>
+              </a:solidFill>
+              <a:latin typeface="Microsoft YaHei"/>
+            </a:defRPr>
+          </a:pPr>
+        </a:p>
+      </c:txPr>
+    </c:legend>
     <c:dispBlanksAs val="gap"/>
   </c:chart>
   <c:txPr>
@@ -224,6 +383,9 @@
     <a:p>
       <a:pPr>
         <a:defRPr sz="1100">
+          <a:solidFill>
+            <a:srgbClr val="FFFFFF"/>
+          </a:solidFill>
           <a:latin typeface="Microsoft YaHei"/>
         </a:defRPr>
       </a:pPr>
@@ -5723,8 +5885,8 @@
         </p:nvSpPr>
         <p:spPr>
           <a:xfrm>
-            <a:off x="0" y="2834640"/>
-            <a:ext cx="12191695" cy="1188720"/>
+            <a:off x="0" y="2468880"/>
+            <a:ext cx="12191695" cy="1828800"/>
           </a:xfrm>
           <a:prstGeom prst="rect">
             <a:avLst/>
@@ -5767,8 +5929,8 @@
         </p:nvSpPr>
         <p:spPr>
           <a:xfrm>
-            <a:off x="0" y="2834640"/>
-            <a:ext cx="164592" cy="1188720"/>
+            <a:off x="0" y="2468880"/>
+            <a:ext cx="164592" cy="1828800"/>
           </a:xfrm>
           <a:prstGeom prst="rect">
             <a:avLst/>
@@ -5811,9 +5973,91 @@
         </p:nvSpPr>
         <p:spPr>
           <a:xfrm>
-            <a:off x="548640" y="2999232"/>
-            <a:ext cx="822960" cy="822960"/>
-          </a:xfrm>
+            <a:off x="3108960" y="2651760"/>
+            <a:ext cx="18288" cy="1463040"/>
+          </a:xfrm>
+          <a:prstGeom prst="rect">
+            <a:avLst/>
+          </a:prstGeom>
+          <a:solidFill>
+            <a:srgbClr val="30363D"/>
+          </a:solidFill>
+          <a:ln>
+            <a:noFill/>
+          </a:ln>
+          <a:effectLst/>
+        </p:spPr>
+        <p:style>
+          <a:lnRef idx="1">
+            <a:schemeClr val="accent1"/>
+          </a:lnRef>
+          <a:fillRef idx="3">
+            <a:schemeClr val="accent1"/>
+          </a:fillRef>
+          <a:effectRef idx="2">
+            <a:schemeClr val="accent1"/>
+          </a:effectRef>
+          <a:fontRef idx="minor">
+            <a:schemeClr val="lt1"/>
+          </a:fontRef>
+        </p:style>
+        <p:txBody>
+          <a:bodyPr rtlCol="0" anchor="ctr"/>
+          <a:lstStyle/>
+          <a:p>
+            <a:pPr algn="ctr"/>
+          </a:p>
+        </p:txBody>
+      </p:sp>
+      <p:sp>
+        <p:nvSpPr>
+          <p:cNvPr id="5" name="TextBox 4"/>
+          <p:cNvSpPr txBox="1"/>
+          <p:nvPr/>
+        </p:nvSpPr>
+        <p:spPr>
+          <a:xfrm>
+            <a:off x="548640" y="2468880"/>
+            <a:ext cx="2377440" cy="1828800"/>
+          </a:xfrm>
+          <a:prstGeom prst="rect">
+            <a:avLst/>
+          </a:prstGeom>
+          <a:noFill/>
+        </p:spPr>
+        <p:txBody>
+          <a:bodyPr wrap="square" anchor="ctr" lIns="45720" rIns="45720">
+            <a:spAutoFit/>
+          </a:bodyPr>
+          <a:lstStyle/>
+          <a:p>
+            <a:pPr algn="ctr"/>
+            <a:r>
+              <a:rPr sz="9600" b="1" i="0">
+                <a:solidFill>
+                  <a:srgbClr val="3FB950"/>
+                </a:solidFill>
+                <a:latin typeface="Microsoft YaHei"/>
+              </a:rPr>
+              <a:t>01</a:t>
+            </a:r>
+          </a:p>
+        </p:txBody>
+      </p:sp>
+      <p:sp>
+        <p:nvSpPr>
+          <p:cNvPr id="6" name="Oval 5"/>
+          <p:cNvSpPr/>
+          <p:nvPr/>
+        </p:nvSpPr>
+        <p:spPr>
+          <a:xfrm>
+            <a:off x="10332720" y="2697480"/>
+            <a:ext cx="1188720" cy="1188720"/>
+          </a:xfrm>
+          <a:prstGeom prst="ellipse">
+            <a:avLst/>
+          </a:prstGeom>
           <a:noFill/>
           <a:ln w="19050">
             <a:solidFill>
@@ -5821,31 +6065,6 @@
             </a:solidFill>
           </a:ln>
           <a:effectLst/>
-          <a:custGeom>
-            <a:pathLst>
-              <a:path w="100000" h="100000">
-                <a:moveTo>
-                  <a:pt x="30000" y="18000"/>
-                </a:moveTo>
-                <a:lnTo>
-                  <a:pt x="70000" y="18000"/>
-                </a:lnTo>
-                <a:lnTo>
-                  <a:pt x="70000" y="82000"/>
-                </a:lnTo>
-                <a:lnTo>
-                  <a:pt x="50000" y="66000"/>
-                </a:lnTo>
-                <a:lnTo>
-                  <a:pt x="30000" y="82000"/>
-                </a:lnTo>
-                <a:lnTo>
-                  <a:pt x="30000" y="18000"/>
-                </a:lnTo>
-                <a:close/>
-              </a:path>
-            </a:pathLst>
-          </a:custGeom>
         </p:spPr>
         <p:style>
           <a:lnRef idx="1">
@@ -5871,14 +6090,14 @@
       </p:sp>
       <p:sp>
         <p:nvSpPr>
-          <p:cNvPr id="5" name="TextBox 4"/>
+          <p:cNvPr id="7" name="TextBox 6"/>
           <p:cNvSpPr txBox="1"/>
           <p:nvPr/>
         </p:nvSpPr>
         <p:spPr>
           <a:xfrm>
-            <a:off x="1554480" y="2971800"/>
-            <a:ext cx="10058400" cy="914400"/>
+            <a:off x="3383280" y="2697480"/>
+            <a:ext cx="6766560" cy="914400"/>
           </a:xfrm>
           <a:prstGeom prst="rect">
             <a:avLst/>
@@ -5899,21 +6118,21 @@
                 </a:solidFill>
                 <a:latin typeface="Microsoft YaHei"/>
               </a:rPr>
-              <a:t>01 市场机会</a:t>
-            </a:r>
-          </a:p>
-        </p:txBody>
-      </p:sp>
-      <p:sp>
-        <p:nvSpPr>
-          <p:cNvPr id="6" name="TextBox 5"/>
+              <a:t>市场机会</a:t>
+            </a:r>
+          </a:p>
+        </p:txBody>
+      </p:sp>
+      <p:sp>
+        <p:nvSpPr>
+          <p:cNvPr id="8" name="TextBox 7"/>
           <p:cNvSpPr txBox="1"/>
           <p:nvPr/>
         </p:nvSpPr>
         <p:spPr>
           <a:xfrm>
-            <a:off x="1554480" y="3886200"/>
-            <a:ext cx="10058400" cy="457200"/>
+            <a:off x="3383280" y="3977639"/>
+            <a:ext cx="6766560" cy="457200"/>
           </a:xfrm>
           <a:prstGeom prst="rect">
             <a:avLst/>
@@ -7088,8 +7307,8 @@
         </p:nvSpPr>
         <p:spPr>
           <a:xfrm>
-            <a:off x="0" y="2834640"/>
-            <a:ext cx="12191695" cy="1188720"/>
+            <a:off x="0" y="2468880"/>
+            <a:ext cx="12191695" cy="1828800"/>
           </a:xfrm>
           <a:prstGeom prst="rect">
             <a:avLst/>
@@ -7132,8 +7351,8 @@
         </p:nvSpPr>
         <p:spPr>
           <a:xfrm>
-            <a:off x="0" y="2834640"/>
-            <a:ext cx="164592" cy="1188720"/>
+            <a:off x="0" y="2468880"/>
+            <a:ext cx="164592" cy="1828800"/>
           </a:xfrm>
           <a:prstGeom prst="rect">
             <a:avLst/>
@@ -7176,9 +7395,91 @@
         </p:nvSpPr>
         <p:spPr>
           <a:xfrm>
-            <a:off x="548640" y="2999232"/>
-            <a:ext cx="822960" cy="822960"/>
-          </a:xfrm>
+            <a:off x="3108960" y="2651760"/>
+            <a:ext cx="18288" cy="1463040"/>
+          </a:xfrm>
+          <a:prstGeom prst="rect">
+            <a:avLst/>
+          </a:prstGeom>
+          <a:solidFill>
+            <a:srgbClr val="30363D"/>
+          </a:solidFill>
+          <a:ln>
+            <a:noFill/>
+          </a:ln>
+          <a:effectLst/>
+        </p:spPr>
+        <p:style>
+          <a:lnRef idx="1">
+            <a:schemeClr val="accent1"/>
+          </a:lnRef>
+          <a:fillRef idx="3">
+            <a:schemeClr val="accent1"/>
+          </a:fillRef>
+          <a:effectRef idx="2">
+            <a:schemeClr val="accent1"/>
+          </a:effectRef>
+          <a:fontRef idx="minor">
+            <a:schemeClr val="lt1"/>
+          </a:fontRef>
+        </p:style>
+        <p:txBody>
+          <a:bodyPr rtlCol="0" anchor="ctr"/>
+          <a:lstStyle/>
+          <a:p>
+            <a:pPr algn="ctr"/>
+          </a:p>
+        </p:txBody>
+      </p:sp>
+      <p:sp>
+        <p:nvSpPr>
+          <p:cNvPr id="5" name="TextBox 4"/>
+          <p:cNvSpPr txBox="1"/>
+          <p:nvPr/>
+        </p:nvSpPr>
+        <p:spPr>
+          <a:xfrm>
+            <a:off x="548640" y="2468880"/>
+            <a:ext cx="2377440" cy="1828800"/>
+          </a:xfrm>
+          <a:prstGeom prst="rect">
+            <a:avLst/>
+          </a:prstGeom>
+          <a:noFill/>
+        </p:spPr>
+        <p:txBody>
+          <a:bodyPr wrap="square" anchor="ctr" lIns="45720" rIns="45720">
+            <a:spAutoFit/>
+          </a:bodyPr>
+          <a:lstStyle/>
+          <a:p>
+            <a:pPr algn="ctr"/>
+            <a:r>
+              <a:rPr sz="9600" b="1" i="0">
+                <a:solidFill>
+                  <a:srgbClr val="3FB950"/>
+                </a:solidFill>
+                <a:latin typeface="Microsoft YaHei"/>
+              </a:rPr>
+              <a:t>02</a:t>
+            </a:r>
+          </a:p>
+        </p:txBody>
+      </p:sp>
+      <p:sp>
+        <p:nvSpPr>
+          <p:cNvPr id="6" name="Oval 5"/>
+          <p:cNvSpPr/>
+          <p:nvPr/>
+        </p:nvSpPr>
+        <p:spPr>
+          <a:xfrm>
+            <a:off x="10332720" y="2697480"/>
+            <a:ext cx="1188720" cy="1188720"/>
+          </a:xfrm>
+          <a:prstGeom prst="ellipse">
+            <a:avLst/>
+          </a:prstGeom>
           <a:noFill/>
           <a:ln w="19050">
             <a:solidFill>
@@ -7186,31 +7487,6 @@
             </a:solidFill>
           </a:ln>
           <a:effectLst/>
-          <a:custGeom>
-            <a:pathLst>
-              <a:path w="100000" h="100000">
-                <a:moveTo>
-                  <a:pt x="30000" y="18000"/>
-                </a:moveTo>
-                <a:lnTo>
-                  <a:pt x="70000" y="18000"/>
-                </a:lnTo>
-                <a:lnTo>
-                  <a:pt x="70000" y="82000"/>
-                </a:lnTo>
-                <a:lnTo>
-                  <a:pt x="50000" y="66000"/>
-                </a:lnTo>
-                <a:lnTo>
-                  <a:pt x="30000" y="82000"/>
-                </a:lnTo>
-                <a:lnTo>
-                  <a:pt x="30000" y="18000"/>
-                </a:lnTo>
-                <a:close/>
-              </a:path>
-            </a:pathLst>
-          </a:custGeom>
         </p:spPr>
         <p:style>
           <a:lnRef idx="1">
@@ -7236,14 +7512,14 @@
       </p:sp>
       <p:sp>
         <p:nvSpPr>
-          <p:cNvPr id="5" name="TextBox 4"/>
+          <p:cNvPr id="7" name="TextBox 6"/>
           <p:cNvSpPr txBox="1"/>
           <p:nvPr/>
         </p:nvSpPr>
         <p:spPr>
           <a:xfrm>
-            <a:off x="1554480" y="2971800"/>
-            <a:ext cx="10058400" cy="914400"/>
+            <a:off x="3383280" y="2697480"/>
+            <a:ext cx="6766560" cy="914400"/>
           </a:xfrm>
           <a:prstGeom prst="rect">
             <a:avLst/>
@@ -7264,21 +7540,21 @@
                 </a:solidFill>
                 <a:latin typeface="Microsoft YaHei"/>
               </a:rPr>
-              <a:t>02 产品矩阵</a:t>
-            </a:r>
-          </a:p>
-        </p:txBody>
-      </p:sp>
-      <p:sp>
-        <p:nvSpPr>
-          <p:cNvPr id="6" name="TextBox 5"/>
+              <a:t>产品矩阵</a:t>
+            </a:r>
+          </a:p>
+        </p:txBody>
+      </p:sp>
+      <p:sp>
+        <p:nvSpPr>
+          <p:cNvPr id="8" name="TextBox 7"/>
           <p:cNvSpPr txBox="1"/>
           <p:nvPr/>
         </p:nvSpPr>
         <p:spPr>
           <a:xfrm>
-            <a:off x="1554480" y="3886200"/>
-            <a:ext cx="10058400" cy="457200"/>
+            <a:off x="3383280" y="3977639"/>
+            <a:ext cx="6766560" cy="457200"/>
           </a:xfrm>
           <a:prstGeom prst="rect">
             <a:avLst/>

</xml_diff>